<commit_message>
T2D digital twin PoC
</commit_message>
<xml_diff>
--- a/docs/presentation.pptx
+++ b/docs/presentation.pptx
@@ -15,9 +15,11 @@
     <p:sldId id="263" r:id="rId9"/>
     <p:sldId id="264" r:id="rId10"/>
     <p:sldId id="265" r:id="rId11"/>
+    <p:sldId id="266" r:id="rId12"/>
+    <p:sldId id="267" r:id="rId13"/>
   </p:sldIdLst>
   <p:notesMasterIdLst>
-    <p:notesMasterId r:id="rId12"/>
+    <p:notesMasterId r:id="rId14"/>
   </p:notesMasterIdLst>
   <p:sldSz cx="12192000" cy="6858000"/>
   <p:notesSz cx="6858000" cy="12192000"/>
@@ -166,26 +168,26 @@
               <c:strCache>
                 <c:ptCount val="1"/>
                 <c:pt idx="0">
-                  <c:v>ROC-AUC</c:v>
+                  <c:v>High (&gt;180)</c:v>
                 </c:pt>
               </c:strCache>
             </c:strRef>
           </c:tx>
           <c:spPr>
             <a:solidFill>
-              <a:srgbClr val="B7D9EE"/>
+              <a:srgbClr val="3FA796"/>
             </a:solidFill>
             <a:effectLst/>
           </c:spPr>
           <c:invertIfNegative val="0"/>
           <c:dLbls>
-            <c:numFmt formatCode="0.000" sourceLinked="0"/>
+            <c:numFmt formatCode="0.00" sourceLinked="0"/>
             <c:txPr>
               <a:bodyPr/>
               <a:lstStyle/>
               <a:p>
                 <a:pPr>
-                  <a:defRPr b="0" i="0" strike="noStrike" sz="1400" u="none">
+                  <a:defRPr b="0" i="0" strike="noStrike" sz="1200" u="none">
                     <a:solidFill>
                       <a:srgbClr val="1F3A33"/>
                     </a:solidFill>
@@ -202,39 +204,6 @@
             <c:showBubbleSize val="0"/>
             <c:showLeaderLines val="0"/>
           </c:dLbls>
-          <c:dPt>
-            <c:idx val="0"/>
-            <c:invertIfNegative val="0"/>
-            <c:bubble3D val="0"/>
-            <c:spPr>
-              <a:solidFill>
-                <a:srgbClr val="B7D9EE"/>
-              </a:solidFill>
-              <a:effectLst/>
-            </c:spPr>
-          </c:dPt>
-          <c:dPt>
-            <c:idx val="1"/>
-            <c:invertIfNegative val="0"/>
-            <c:bubble3D val="0"/>
-            <c:spPr>
-              <a:solidFill>
-                <a:srgbClr val="8EC5E8"/>
-              </a:solidFill>
-              <a:effectLst/>
-            </c:spPr>
-          </c:dPt>
-          <c:dPt>
-            <c:idx val="2"/>
-            <c:invertIfNegative val="0"/>
-            <c:bubble3D val="0"/>
-            <c:spPr>
-              <a:solidFill>
-                <a:srgbClr val="3FA796"/>
-              </a:solidFill>
-              <a:effectLst/>
-            </c:spPr>
-          </c:dPt>
           <c:cat>
             <c:multiLvlStrRef>
               <c:f>Sheet1!$A$2:$A$4</c:f>
@@ -261,26 +230,109 @@
                 <c:formatCode>General</c:formatCode>
                 <c:ptCount val="3"/>
                 <c:pt idx="0">
-                  <c:v>0.782</c:v>
+                  <c:v>0.788</c:v>
                 </c:pt>
                 <c:pt idx="1">
-                  <c:v>0.948</c:v>
+                  <c:v>0.936</c:v>
                 </c:pt>
                 <c:pt idx="2">
-                  <c:v>0.958</c:v>
+                  <c:v>0.947</c:v>
+                </c:pt>
+              </c:numCache>
+            </c:numRef>
+          </c:val>
+        </c:ser>
+        <c:ser>
+          <c:idx val="1"/>
+          <c:order val="1"/>
+          <c:tx>
+            <c:strRef>
+              <c:f>Sheet1!$C$1</c:f>
+              <c:strCache>
+                <c:ptCount val="1"/>
+                <c:pt idx="0">
+                  <c:v>Low (&lt;70)</c:v>
+                </c:pt>
+              </c:strCache>
+            </c:strRef>
+          </c:tx>
+          <c:spPr>
+            <a:solidFill>
+              <a:srgbClr val="6FB3E0"/>
+            </a:solidFill>
+            <a:effectLst/>
+          </c:spPr>
+          <c:invertIfNegative val="0"/>
+          <c:dLbls>
+            <c:numFmt formatCode="0.00" sourceLinked="0"/>
+            <c:txPr>
+              <a:bodyPr/>
+              <a:lstStyle/>
+              <a:p>
+                <a:pPr>
+                  <a:defRPr b="0" i="0" strike="noStrike" sz="1200" u="none">
+                    <a:solidFill>
+                      <a:srgbClr val="1F3A33"/>
+                    </a:solidFill>
+                    <a:latin typeface="Calibri"/>
+                  </a:defRPr>
+                </a:pPr>
+              </a:p>
+            </c:txPr>
+            <c:showLegendKey val="0"/>
+            <c:showVal val="1"/>
+            <c:showCatName val="0"/>
+            <c:showSerName val="0"/>
+            <c:showPercent val="0"/>
+            <c:showBubbleSize val="0"/>
+            <c:showLeaderLines val="0"/>
+          </c:dLbls>
+          <c:cat>
+            <c:multiLvlStrRef>
+              <c:f>Sheet1!$A$2:$A$4</c:f>
+              <c:multiLvlStrCache>
+                <c:ptCount val="3"/>
+                <c:lvl>
+                  <c:pt idx="0">
+                    <c:v>CGM only</c:v>
+                  </c:pt>
+                  <c:pt idx="1">
+                    <c:v>+ wearable</c:v>
+                  </c:pt>
+                  <c:pt idx="2">
+                    <c:v>+ wearable + EHR</c:v>
+                  </c:pt>
+                </c:lvl>
+              </c:multiLvlStrCache>
+            </c:multiLvlStrRef>
+          </c:cat>
+          <c:val>
+            <c:numRef>
+              <c:f>Sheet1!$C$2:$C$4</c:f>
+              <c:numCache>
+                <c:formatCode>General</c:formatCode>
+                <c:ptCount val="3"/>
+                <c:pt idx="0">
+                  <c:v>0.942</c:v>
+                </c:pt>
+                <c:pt idx="1">
+                  <c:v>0.962</c:v>
+                </c:pt>
+                <c:pt idx="2">
+                  <c:v>0.981</c:v>
                 </c:pt>
               </c:numCache>
             </c:numRef>
           </c:val>
         </c:ser>
         <c:dLbls>
-          <c:numFmt formatCode="0.000" sourceLinked="0"/>
+          <c:numFmt formatCode="0.00" sourceLinked="0"/>
           <c:txPr>
             <a:bodyPr/>
             <a:lstStyle/>
             <a:p>
               <a:pPr>
-                <a:defRPr b="0" i="0" strike="noStrike" sz="1400" u="none">
+                <a:defRPr b="0" i="0" strike="noStrike" sz="1200" u="none">
                   <a:solidFill>
                     <a:srgbClr val="1F3A33"/>
                   </a:solidFill>
@@ -349,7 +401,7 @@
         <c:scaling>
           <c:orientation val="minMax"/>
           <c:max val="1"/>
-          <c:min val="0"/>
+          <c:min val="0.5"/>
         </c:scaling>
         <c:delete val="0"/>
         <c:axPos val="l"/>
@@ -395,7 +447,7 @@
         <c:crossAx val="2094734554"/>
         <c:crosses val="autoZero"/>
         <c:crossBetween val="between"/>
-        <c:majorUnit val="0.25"/>
+        <c:majorUnit val="0.1"/>
       </c:valAx>
       <c:spPr>
         <a:noFill/>
@@ -405,6 +457,26 @@
         <a:effectLst/>
       </c:spPr>
     </c:plotArea>
+    <c:legend>
+      <c:legendPos val="b"/>
+      <c:overlay val="0"/>
+      <c:txPr>
+        <a:bodyPr/>
+        <a:lstStyle/>
+        <a:p>
+          <a:pPr>
+            <a:defRPr sz="1200">
+              <a:solidFill>
+                <a:srgbClr val="1F3A33"/>
+              </a:solidFill>
+              <a:latin typeface="Calibri"/>
+              <a:cs typeface="Calibri"/>
+            </a:defRPr>
+          </a:pPr>
+          <a:endParaRPr lang="en-US"/>
+        </a:p>
+      </c:txPr>
+    </c:legend>
     <c:plotVisOnly val="1"/>
     <c:dispBlanksAs val="span"/>
   </c:chart>
@@ -703,7 +775,7 @@
               <c:strCache>
                 <c:ptCount val="1"/>
                 <c:pt idx="0">
-                  <c:v>180 mg/dL threshold</c:v>
+                  <c:v>180 mg/dL high threshold</c:v>
                 </c:pt>
               </c:strCache>
             </c:strRef>
@@ -928,6 +1000,240 @@
           </c:val>
           <c:smooth val="0"/>
         </c:ser>
+        <c:ser>
+          <c:idx val="2"/>
+          <c:order val="2"/>
+          <c:tx>
+            <c:strRef>
+              <c:f>Sheet1!$D$1</c:f>
+              <c:strCache>
+                <c:ptCount val="1"/>
+                <c:pt idx="0">
+                  <c:v>70 mg/dL low threshold</c:v>
+                </c:pt>
+              </c:strCache>
+            </c:strRef>
+          </c:tx>
+          <c:spPr>
+            <a:solidFill>
+              <a:srgbClr val="6FB3E0"/>
+            </a:solidFill>
+            <a:ln w="31750" cap="flat">
+              <a:solidFill>
+                <a:srgbClr val="6FB3E0"/>
+              </a:solidFill>
+              <a:prstDash val="solid"/>
+              <a:round/>
+            </a:ln>
+            <a:effectLst/>
+          </c:spPr>
+          <c:invertIfNegative val="0"/>
+          <c:dLbls>
+            <c:numFmt formatCode="#,##0" sourceLinked="0"/>
+            <c:txPr>
+              <a:bodyPr/>
+              <a:lstStyle/>
+              <a:p>
+                <a:pPr>
+                  <a:defRPr b="0" i="0" strike="noStrike" sz="1200" u="none">
+                    <a:solidFill>
+                      <a:srgbClr val="000000"/>
+                    </a:solidFill>
+                    <a:latin typeface="Arial"/>
+                  </a:defRPr>
+                </a:pPr>
+              </a:p>
+            </c:txPr>
+            <c:showLegendKey val="0"/>
+            <c:showVal val="0"/>
+            <c:showCatName val="0"/>
+            <c:showSerName val="0"/>
+            <c:showPercent val="0"/>
+            <c:showBubbleSize val="0"/>
+            <c:showLeaderLines val="0"/>
+          </c:dLbls>
+          <c:marker>
+            <c:symbol val="none"/>
+            <c:size val="6"/>
+            <c:spPr>
+              <a:solidFill>
+                <a:srgbClr val="6FB3E0"/>
+              </a:solidFill>
+              <a:ln w="9525" cap="flat">
+                <a:solidFill>
+                  <a:srgbClr val="6FB3E0"/>
+                </a:solidFill>
+                <a:prstDash val="solid"/>
+                <a:round/>
+              </a:ln>
+              <a:effectLst/>
+            </c:spPr>
+          </c:marker>
+          <c:cat>
+            <c:multiLvlStrRef>
+              <c:f>Sheet1!$A$2:$A$25</c:f>
+              <c:multiLvlStrCache>
+                <c:ptCount val="24"/>
+                <c:lvl>
+                  <c:pt idx="0">
+                    <c:v>00:00</c:v>
+                  </c:pt>
+                  <c:pt idx="1">
+                    <c:v>01:00</c:v>
+                  </c:pt>
+                  <c:pt idx="2">
+                    <c:v>02:00</c:v>
+                  </c:pt>
+                  <c:pt idx="3">
+                    <c:v>03:00</c:v>
+                  </c:pt>
+                  <c:pt idx="4">
+                    <c:v>04:00</c:v>
+                  </c:pt>
+                  <c:pt idx="5">
+                    <c:v>05:00</c:v>
+                  </c:pt>
+                  <c:pt idx="6">
+                    <c:v>06:00</c:v>
+                  </c:pt>
+                  <c:pt idx="7">
+                    <c:v>07:00</c:v>
+                  </c:pt>
+                  <c:pt idx="8">
+                    <c:v>08:00</c:v>
+                  </c:pt>
+                  <c:pt idx="9">
+                    <c:v>09:00</c:v>
+                  </c:pt>
+                  <c:pt idx="10">
+                    <c:v>10:00</c:v>
+                  </c:pt>
+                  <c:pt idx="11">
+                    <c:v>11:00</c:v>
+                  </c:pt>
+                  <c:pt idx="12">
+                    <c:v>12:00</c:v>
+                  </c:pt>
+                  <c:pt idx="13">
+                    <c:v>13:00</c:v>
+                  </c:pt>
+                  <c:pt idx="14">
+                    <c:v>14:00</c:v>
+                  </c:pt>
+                  <c:pt idx="15">
+                    <c:v>15:00</c:v>
+                  </c:pt>
+                  <c:pt idx="16">
+                    <c:v>16:00</c:v>
+                  </c:pt>
+                  <c:pt idx="17">
+                    <c:v>17:00</c:v>
+                  </c:pt>
+                  <c:pt idx="18">
+                    <c:v>18:00</c:v>
+                  </c:pt>
+                  <c:pt idx="19">
+                    <c:v>19:00</c:v>
+                  </c:pt>
+                  <c:pt idx="20">
+                    <c:v>20:00</c:v>
+                  </c:pt>
+                  <c:pt idx="21">
+                    <c:v>21:00</c:v>
+                  </c:pt>
+                  <c:pt idx="22">
+                    <c:v>22:00</c:v>
+                  </c:pt>
+                  <c:pt idx="23">
+                    <c:v>23:00</c:v>
+                  </c:pt>
+                </c:lvl>
+              </c:multiLvlStrCache>
+            </c:multiLvlStrRef>
+          </c:cat>
+          <c:val>
+            <c:numRef>
+              <c:f>Sheet1!$D$2:$D$25</c:f>
+              <c:numCache>
+                <c:formatCode>General</c:formatCode>
+                <c:ptCount val="24"/>
+                <c:pt idx="0">
+                  <c:v>70</c:v>
+                </c:pt>
+                <c:pt idx="1">
+                  <c:v>70</c:v>
+                </c:pt>
+                <c:pt idx="2">
+                  <c:v>70</c:v>
+                </c:pt>
+                <c:pt idx="3">
+                  <c:v>70</c:v>
+                </c:pt>
+                <c:pt idx="4">
+                  <c:v>70</c:v>
+                </c:pt>
+                <c:pt idx="5">
+                  <c:v>70</c:v>
+                </c:pt>
+                <c:pt idx="6">
+                  <c:v>70</c:v>
+                </c:pt>
+                <c:pt idx="7">
+                  <c:v>70</c:v>
+                </c:pt>
+                <c:pt idx="8">
+                  <c:v>70</c:v>
+                </c:pt>
+                <c:pt idx="9">
+                  <c:v>70</c:v>
+                </c:pt>
+                <c:pt idx="10">
+                  <c:v>70</c:v>
+                </c:pt>
+                <c:pt idx="11">
+                  <c:v>70</c:v>
+                </c:pt>
+                <c:pt idx="12">
+                  <c:v>70</c:v>
+                </c:pt>
+                <c:pt idx="13">
+                  <c:v>70</c:v>
+                </c:pt>
+                <c:pt idx="14">
+                  <c:v>70</c:v>
+                </c:pt>
+                <c:pt idx="15">
+                  <c:v>70</c:v>
+                </c:pt>
+                <c:pt idx="16">
+                  <c:v>70</c:v>
+                </c:pt>
+                <c:pt idx="17">
+                  <c:v>70</c:v>
+                </c:pt>
+                <c:pt idx="18">
+                  <c:v>70</c:v>
+                </c:pt>
+                <c:pt idx="19">
+                  <c:v>70</c:v>
+                </c:pt>
+                <c:pt idx="20">
+                  <c:v>70</c:v>
+                </c:pt>
+                <c:pt idx="21">
+                  <c:v>70</c:v>
+                </c:pt>
+                <c:pt idx="22">
+                  <c:v>70</c:v>
+                </c:pt>
+                <c:pt idx="23">
+                  <c:v>70</c:v>
+                </c:pt>
+              </c:numCache>
+            </c:numRef>
+          </c:val>
+          <c:smooth val="0"/>
+        </c:ser>
         <c:dLbls>
           <c:numFmt formatCode="#,##0" sourceLinked="0"/>
           <c:txPr>
@@ -1600,6 +1906,182 @@
             <a:fld id="{F7021451-1387-4CA6-816F-3879F97B5CBC}" type="slidenum">
               <a:rPr lang="en-US"/>
               <a:t>10</a:t>
+            </a:fld>
+            <a:endParaRPr lang="en-US"/>
+          </a:p>
+        </p:txBody>
+      </p:sp>
+    </p:spTree>
+    <p:extLst>
+      <p:ext uri="{BB962C8B-B14F-4D97-AF65-F5344CB8AC3E}">
+        <p14:creationId xmlns:p14="http://schemas.microsoft.com/office/powerpoint/2010/main" val="1024086991"/>
+      </p:ext>
+    </p:extLst>
+  </p:cSld>
+  <p:clrMapOvr>
+    <a:masterClrMapping/>
+  </p:clrMapOvr>
+</p:notes>
+</file>
+
+<file path=ppt/notesSlides/notesSlide11.xml><?xml version="1.0" encoding="utf-8"?>
+<p:notes xmlns:a="http://schemas.openxmlformats.org/drawingml/2006/main" xmlns:r="http://schemas.openxmlformats.org/officeDocument/2006/relationships" xmlns:p="http://schemas.openxmlformats.org/presentationml/2006/main">
+  <p:cSld>
+    <p:spTree>
+      <p:nvGrpSpPr>
+        <p:cNvPr id="1" name=""/>
+        <p:cNvGrpSpPr/>
+        <p:nvPr/>
+      </p:nvGrpSpPr>
+      <p:grpSpPr>
+        <a:xfrm>
+          <a:off x="0" y="0"/>
+          <a:ext cx="0" cy="0"/>
+          <a:chOff x="0" y="0"/>
+          <a:chExt cx="0" cy="0"/>
+        </a:xfrm>
+      </p:grpSpPr>
+      <p:sp>
+        <p:nvSpPr>
+          <p:cNvPr id="2" name="Slide Image Placeholder 1"/>
+          <p:cNvSpPr>
+            <a:spLocks noGrp="1" noRot="1" noChangeAspect="1"/>
+          </p:cNvSpPr>
+          <p:nvPr>
+            <p:ph type="sldImg"/>
+          </p:nvPr>
+        </p:nvSpPr>
+        <p:spPr/>
+      </p:sp>
+      <p:sp>
+        <p:nvSpPr>
+          <p:cNvPr id="3" name="Notes Placeholder 2"/>
+          <p:cNvSpPr>
+            <a:spLocks noGrp="1"/>
+          </p:cNvSpPr>
+          <p:nvPr>
+            <p:ph type="body" idx="1"/>
+          </p:nvPr>
+        </p:nvSpPr>
+        <p:spPr/>
+        <p:txBody>
+          <a:bodyPr/>
+          <a:lstStyle/>
+          <a:p>
+            <a:r>
+              <a:rPr lang="en-US" dirty="0"/>
+              <a:t/>
+            </a:r>
+            <a:endParaRPr lang="en-US" dirty="0"/>
+          </a:p>
+        </p:txBody>
+      </p:sp>
+      <p:sp>
+        <p:nvSpPr>
+          <p:cNvPr id="4" name="Slide Number Placeholder 3"/>
+          <p:cNvSpPr>
+            <a:spLocks noGrp="1"/>
+          </p:cNvSpPr>
+          <p:nvPr>
+            <p:ph type="sldNum" sz="quarter" idx="10"/>
+          </p:nvPr>
+        </p:nvSpPr>
+        <p:spPr/>
+        <p:txBody>
+          <a:bodyPr/>
+          <a:lstStyle/>
+          <a:p>
+            <a:fld id="{F7021451-1387-4CA6-816F-3879F97B5CBC}" type="slidenum">
+              <a:rPr lang="en-US"/>
+              <a:t>11</a:t>
+            </a:fld>
+            <a:endParaRPr lang="en-US"/>
+          </a:p>
+        </p:txBody>
+      </p:sp>
+    </p:spTree>
+    <p:extLst>
+      <p:ext uri="{BB962C8B-B14F-4D97-AF65-F5344CB8AC3E}">
+        <p14:creationId xmlns:p14="http://schemas.microsoft.com/office/powerpoint/2010/main" val="1024086991"/>
+      </p:ext>
+    </p:extLst>
+  </p:cSld>
+  <p:clrMapOvr>
+    <a:masterClrMapping/>
+  </p:clrMapOvr>
+</p:notes>
+</file>
+
+<file path=ppt/notesSlides/notesSlide12.xml><?xml version="1.0" encoding="utf-8"?>
+<p:notes xmlns:a="http://schemas.openxmlformats.org/drawingml/2006/main" xmlns:r="http://schemas.openxmlformats.org/officeDocument/2006/relationships" xmlns:p="http://schemas.openxmlformats.org/presentationml/2006/main">
+  <p:cSld>
+    <p:spTree>
+      <p:nvGrpSpPr>
+        <p:cNvPr id="1" name=""/>
+        <p:cNvGrpSpPr/>
+        <p:nvPr/>
+      </p:nvGrpSpPr>
+      <p:grpSpPr>
+        <a:xfrm>
+          <a:off x="0" y="0"/>
+          <a:ext cx="0" cy="0"/>
+          <a:chOff x="0" y="0"/>
+          <a:chExt cx="0" cy="0"/>
+        </a:xfrm>
+      </p:grpSpPr>
+      <p:sp>
+        <p:nvSpPr>
+          <p:cNvPr id="2" name="Slide Image Placeholder 1"/>
+          <p:cNvSpPr>
+            <a:spLocks noGrp="1" noRot="1" noChangeAspect="1"/>
+          </p:cNvSpPr>
+          <p:nvPr>
+            <p:ph type="sldImg"/>
+          </p:nvPr>
+        </p:nvSpPr>
+        <p:spPr/>
+      </p:sp>
+      <p:sp>
+        <p:nvSpPr>
+          <p:cNvPr id="3" name="Notes Placeholder 2"/>
+          <p:cNvSpPr>
+            <a:spLocks noGrp="1"/>
+          </p:cNvSpPr>
+          <p:nvPr>
+            <p:ph type="body" idx="1"/>
+          </p:nvPr>
+        </p:nvSpPr>
+        <p:spPr/>
+        <p:txBody>
+          <a:bodyPr/>
+          <a:lstStyle/>
+          <a:p>
+            <a:r>
+              <a:rPr lang="en-US" dirty="0"/>
+              <a:t/>
+            </a:r>
+            <a:endParaRPr lang="en-US" dirty="0"/>
+          </a:p>
+        </p:txBody>
+      </p:sp>
+      <p:sp>
+        <p:nvSpPr>
+          <p:cNvPr id="4" name="Slide Number Placeholder 3"/>
+          <p:cNvSpPr>
+            <a:spLocks noGrp="1"/>
+          </p:cNvSpPr>
+          <p:nvPr>
+            <p:ph type="sldNum" sz="quarter" idx="10"/>
+          </p:nvPr>
+        </p:nvSpPr>
+        <p:spPr/>
+        <p:txBody>
+          <a:bodyPr/>
+          <a:lstStyle/>
+          <a:p>
+            <a:fld id="{F7021451-1387-4CA6-816F-3879F97B5CBC}" type="slidenum">
+              <a:rPr lang="en-US"/>
+              <a:t>12</a:t>
             </a:fld>
             <a:endParaRPr lang="en-US"/>
           </a:p>
@@ -2878,7 +3360,7 @@
                 <a:ea typeface="Calibri" pitchFamily="34" charset="-122"/>
                 <a:cs typeface="Calibri" pitchFamily="34" charset="-120"/>
               </a:rPr>
-              <a:t>Forecasting hyperglycaemic events by fusing EHR and wearable data streams</a:t>
+              <a:t>Forecasting high and low glucose events 2 hours ahead by fusing EHR and wearable data</a:t>
             </a:r>
             <a:endParaRPr lang="en-US" sz="2200" dirty="0"/>
           </a:p>
@@ -3066,7 +3548,7 @@
                 <a:ea typeface="Cambria" pitchFamily="34" charset="-122"/>
                 <a:cs typeface="Cambria" pitchFamily="34" charset="-120"/>
               </a:rPr>
-              <a:t>Next steps</a:t>
+              <a:t>Clinical safety thinking (SaMD)</a:t>
             </a:r>
             <a:endParaRPr lang="en-US" sz="3600" dirty="0"/>
           </a:p>
@@ -3152,14 +3634,14 @@
       </p:sp>
       <p:sp>
         <p:nvSpPr>
-          <p:cNvPr id="5" name="next-1"/>
+          <p:cNvPr id="5" name="safety-0"/>
           <p:cNvSpPr/>
           <p:nvPr/>
         </p:nvSpPr>
         <p:spPr>
           <a:xfrm>
-            <a:off x="548640" y="1737360"/>
-            <a:ext cx="2606040" cy="3840480"/>
+            <a:off x="548640" y="1554480"/>
+            <a:ext cx="2606040" cy="4389120"/>
           </a:xfrm>
           <a:prstGeom prst="roundRect">
             <a:avLst>
@@ -3186,6 +3668,1110 @@
       </p:sp>
       <p:sp>
         <p:nvSpPr>
+          <p:cNvPr id="6" name="Text 4"/>
+          <p:cNvSpPr txBox="1"/>
+          <p:nvPr/>
+        </p:nvSpPr>
+        <p:spPr>
+          <a:xfrm>
+            <a:off x="822960" y="1828800"/>
+            <a:ext cx="2103120" cy="822960"/>
+          </a:xfrm>
+          <a:prstGeom prst="rect">
+            <a:avLst/>
+          </a:prstGeom>
+          <a:noFill/>
+          <a:ln/>
+        </p:spPr>
+        <p:txBody>
+          <a:bodyPr wrap="square" lIns="0" tIns="0" rIns="0" bIns="0" rtlCol="0" anchor="t"/>
+          <a:lstStyle/>
+          <a:p>
+            <a:pPr indent="0" marL="0">
+              <a:buNone/>
+            </a:pPr>
+            <a:r>
+              <a:rPr lang="en-US" sz="2000" b="1" dirty="0">
+                <a:solidFill>
+                  <a:srgbClr val="3FA796"/>
+                </a:solidFill>
+                <a:latin typeface="Cambria" pitchFamily="34" charset="0"/>
+                <a:ea typeface="Cambria" pitchFamily="34" charset="-122"/>
+                <a:cs typeface="Cambria" pitchFamily="34" charset="-120"/>
+              </a:rPr>
+              <a:t>Intended use</a:t>
+            </a:r>
+            <a:endParaRPr lang="en-US" sz="2000" dirty="0"/>
+          </a:p>
+        </p:txBody>
+      </p:sp>
+      <p:sp>
+        <p:nvSpPr>
+          <p:cNvPr id="7" name="Text 5"/>
+          <p:cNvSpPr txBox="1"/>
+          <p:nvPr/>
+        </p:nvSpPr>
+        <p:spPr>
+          <a:xfrm>
+            <a:off x="822960" y="2743200"/>
+            <a:ext cx="2103120" cy="2926080"/>
+          </a:xfrm>
+          <a:prstGeom prst="rect">
+            <a:avLst/>
+          </a:prstGeom>
+          <a:noFill/>
+          <a:ln/>
+        </p:spPr>
+        <p:txBody>
+          <a:bodyPr wrap="square" lIns="0" tIns="0" rIns="0" bIns="0" rtlCol="0" anchor="t"/>
+          <a:lstStyle/>
+          <a:p>
+            <a:pPr indent="0" marL="0">
+              <a:buNone/>
+            </a:pPr>
+            <a:r>
+              <a:rPr lang="en-US" sz="1500" dirty="0">
+                <a:solidFill>
+                  <a:srgbClr val="1F3A33"/>
+                </a:solidFill>
+                <a:latin typeface="Calibri" pitchFamily="34" charset="0"/>
+                <a:ea typeface="Calibri" pitchFamily="34" charset="-122"/>
+                <a:cs typeface="Calibri" pitchFamily="34" charset="-120"/>
+              </a:rPr>
+              <a:t>Clinician decision support for adults with T2D wearing a CGM. Not for treatment, dosing or replacing device alarms.</a:t>
+            </a:r>
+            <a:endParaRPr lang="en-US" sz="1500" dirty="0"/>
+          </a:p>
+        </p:txBody>
+      </p:sp>
+      <p:sp>
+        <p:nvSpPr>
+          <p:cNvPr id="8" name="safety-1"/>
+          <p:cNvSpPr/>
+          <p:nvPr/>
+        </p:nvSpPr>
+        <p:spPr>
+          <a:xfrm>
+            <a:off x="3364992" y="1554480"/>
+            <a:ext cx="2606040" cy="4389120"/>
+          </a:xfrm>
+          <a:prstGeom prst="roundRect">
+            <a:avLst>
+              <a:gd name="adj" fmla="val 5263"/>
+            </a:avLst>
+          </a:prstGeom>
+          <a:solidFill>
+            <a:srgbClr val="E4F1FA"/>
+          </a:solidFill>
+          <a:ln w="12700">
+            <a:solidFill>
+              <a:srgbClr val="E4F1FA"/>
+            </a:solidFill>
+            <a:prstDash val="solid"/>
+          </a:ln>
+          <a:effectLst>
+            <a:outerShdw sx="100000" sy="100000" kx="0" ky="0" algn="bl" rotWithShape="0" blurRad="101600" dist="25400" dir="5400000">
+              <a:srgbClr val="8FB5A6">
+                <a:alpha val="25000"/>
+              </a:srgbClr>
+            </a:outerShdw>
+          </a:effectLst>
+        </p:spPr>
+      </p:sp>
+      <p:sp>
+        <p:nvSpPr>
+          <p:cNvPr id="9" name="Text 7"/>
+          <p:cNvSpPr txBox="1"/>
+          <p:nvPr/>
+        </p:nvSpPr>
+        <p:spPr>
+          <a:xfrm>
+            <a:off x="3639312" y="1828800"/>
+            <a:ext cx="2103120" cy="822960"/>
+          </a:xfrm>
+          <a:prstGeom prst="rect">
+            <a:avLst/>
+          </a:prstGeom>
+          <a:noFill/>
+          <a:ln/>
+        </p:spPr>
+        <p:txBody>
+          <a:bodyPr wrap="square" lIns="0" tIns="0" rIns="0" bIns="0" rtlCol="0" anchor="t"/>
+          <a:lstStyle/>
+          <a:p>
+            <a:pPr indent="0" marL="0">
+              <a:buNone/>
+            </a:pPr>
+            <a:r>
+              <a:rPr lang="en-US" sz="2000" b="1" dirty="0">
+                <a:solidFill>
+                  <a:srgbClr val="3C8FC4"/>
+                </a:solidFill>
+                <a:latin typeface="Cambria" pitchFamily="34" charset="0"/>
+                <a:ea typeface="Cambria" pitchFamily="34" charset="-122"/>
+                <a:cs typeface="Cambria" pitchFamily="34" charset="-120"/>
+              </a:rPr>
+              <a:t>Likely SaMD class</a:t>
+            </a:r>
+            <a:endParaRPr lang="en-US" sz="2000" dirty="0"/>
+          </a:p>
+        </p:txBody>
+      </p:sp>
+      <p:sp>
+        <p:nvSpPr>
+          <p:cNvPr id="10" name="Text 8"/>
+          <p:cNvSpPr txBox="1"/>
+          <p:nvPr/>
+        </p:nvSpPr>
+        <p:spPr>
+          <a:xfrm>
+            <a:off x="3639312" y="2743200"/>
+            <a:ext cx="2103120" cy="2926080"/>
+          </a:xfrm>
+          <a:prstGeom prst="rect">
+            <a:avLst/>
+          </a:prstGeom>
+          <a:noFill/>
+          <a:ln/>
+        </p:spPr>
+        <p:txBody>
+          <a:bodyPr wrap="square" lIns="0" tIns="0" rIns="0" bIns="0" rtlCol="0" anchor="t"/>
+          <a:lstStyle/>
+          <a:p>
+            <a:pPr indent="0" marL="0">
+              <a:buNone/>
+            </a:pPr>
+            <a:r>
+              <a:rPr lang="en-US" sz="1500" dirty="0">
+                <a:solidFill>
+                  <a:srgbClr val="1F3A33"/>
+                </a:solidFill>
+                <a:latin typeface="Calibri" pitchFamily="34" charset="0"/>
+                <a:ea typeface="Calibri" pitchFamily="34" charset="-122"/>
+                <a:cs typeface="Calibri" pitchFamily="34" charset="-120"/>
+              </a:rPr>
+              <a:t>Software as a Medical Device, plausibly low-to-middle risk (IMDRF I to II). Needs a formal regulatory assessment (CDSCO in India).</a:t>
+            </a:r>
+            <a:endParaRPr lang="en-US" sz="1500" dirty="0"/>
+          </a:p>
+        </p:txBody>
+      </p:sp>
+      <p:sp>
+        <p:nvSpPr>
+          <p:cNvPr id="11" name="safety-2"/>
+          <p:cNvSpPr/>
+          <p:nvPr/>
+        </p:nvSpPr>
+        <p:spPr>
+          <a:xfrm>
+            <a:off x="6181344" y="1554480"/>
+            <a:ext cx="2606040" cy="4389120"/>
+          </a:xfrm>
+          <a:prstGeom prst="roundRect">
+            <a:avLst>
+              <a:gd name="adj" fmla="val 5263"/>
+            </a:avLst>
+          </a:prstGeom>
+          <a:solidFill>
+            <a:srgbClr val="FDEBE3"/>
+          </a:solidFill>
+          <a:ln w="12700">
+            <a:solidFill>
+              <a:srgbClr val="FDEBE3"/>
+            </a:solidFill>
+            <a:prstDash val="solid"/>
+          </a:ln>
+          <a:effectLst>
+            <a:outerShdw sx="100000" sy="100000" kx="0" ky="0" algn="bl" rotWithShape="0" blurRad="101600" dist="25400" dir="5400000">
+              <a:srgbClr val="8FB5A6">
+                <a:alpha val="25000"/>
+              </a:srgbClr>
+            </a:outerShdw>
+          </a:effectLst>
+        </p:spPr>
+      </p:sp>
+      <p:sp>
+        <p:nvSpPr>
+          <p:cNvPr id="12" name="Text 10"/>
+          <p:cNvSpPr txBox="1"/>
+          <p:nvPr/>
+        </p:nvSpPr>
+        <p:spPr>
+          <a:xfrm>
+            <a:off x="6455664" y="1828800"/>
+            <a:ext cx="2103120" cy="822960"/>
+          </a:xfrm>
+          <a:prstGeom prst="rect">
+            <a:avLst/>
+          </a:prstGeom>
+          <a:noFill/>
+          <a:ln/>
+        </p:spPr>
+        <p:txBody>
+          <a:bodyPr wrap="square" lIns="0" tIns="0" rIns="0" bIns="0" rtlCol="0" anchor="t"/>
+          <a:lstStyle/>
+          <a:p>
+            <a:pPr indent="0" marL="0">
+              <a:buNone/>
+            </a:pPr>
+            <a:r>
+              <a:rPr lang="en-US" sz="2000" b="1" dirty="0">
+                <a:solidFill>
+                  <a:srgbClr val="D9785A"/>
+                </a:solidFill>
+                <a:latin typeface="Cambria" pitchFamily="34" charset="0"/>
+                <a:ea typeface="Cambria" pitchFamily="34" charset="-122"/>
+                <a:cs typeface="Cambria" pitchFamily="34" charset="-120"/>
+              </a:rPr>
+              <a:t>Top risks</a:t>
+            </a:r>
+            <a:endParaRPr lang="en-US" sz="2000" dirty="0"/>
+          </a:p>
+        </p:txBody>
+      </p:sp>
+      <p:sp>
+        <p:nvSpPr>
+          <p:cNvPr id="13" name="Text 11"/>
+          <p:cNvSpPr txBox="1"/>
+          <p:nvPr/>
+        </p:nvSpPr>
+        <p:spPr>
+          <a:xfrm>
+            <a:off x="6455664" y="2743200"/>
+            <a:ext cx="2103120" cy="2926080"/>
+          </a:xfrm>
+          <a:prstGeom prst="rect">
+            <a:avLst/>
+          </a:prstGeom>
+          <a:noFill/>
+          <a:ln/>
+        </p:spPr>
+        <p:txBody>
+          <a:bodyPr wrap="square" lIns="0" tIns="0" rIns="0" bIns="0" rtlCol="0" anchor="t"/>
+          <a:lstStyle/>
+          <a:p>
+            <a:pPr indent="0" marL="0">
+              <a:buNone/>
+            </a:pPr>
+            <a:r>
+              <a:rPr lang="en-US" sz="1500" dirty="0">
+                <a:solidFill>
+                  <a:srgbClr val="1F3A33"/>
+                </a:solidFill>
+                <a:latin typeface="Calibri" pitchFamily="34" charset="0"/>
+                <a:ea typeface="Calibri" pitchFamily="34" charset="-122"/>
+                <a:cs typeface="Calibri" pitchFamily="34" charset="-120"/>
+              </a:rPr>
+              <a:t>Missed low alert, false alarms, synthetic-data bias, what-if misread as advice. Each has a mitigation in SAFETY.md.</a:t>
+            </a:r>
+            <a:endParaRPr lang="en-US" sz="1500" dirty="0"/>
+          </a:p>
+        </p:txBody>
+      </p:sp>
+      <p:sp>
+        <p:nvSpPr>
+          <p:cNvPr id="14" name="safety-3"/>
+          <p:cNvSpPr/>
+          <p:nvPr/>
+        </p:nvSpPr>
+        <p:spPr>
+          <a:xfrm>
+            <a:off x="8997696" y="1554480"/>
+            <a:ext cx="2606040" cy="4389120"/>
+          </a:xfrm>
+          <a:prstGeom prst="roundRect">
+            <a:avLst>
+              <a:gd name="adj" fmla="val 5263"/>
+            </a:avLst>
+          </a:prstGeom>
+          <a:solidFill>
+            <a:srgbClr val="DDEFE6"/>
+          </a:solidFill>
+          <a:ln w="12700">
+            <a:solidFill>
+              <a:srgbClr val="DDEFE6"/>
+            </a:solidFill>
+            <a:prstDash val="solid"/>
+          </a:ln>
+          <a:effectLst>
+            <a:outerShdw sx="100000" sy="100000" kx="0" ky="0" algn="bl" rotWithShape="0" blurRad="101600" dist="25400" dir="5400000">
+              <a:srgbClr val="8FB5A6">
+                <a:alpha val="25000"/>
+              </a:srgbClr>
+            </a:outerShdw>
+          </a:effectLst>
+        </p:spPr>
+      </p:sp>
+      <p:sp>
+        <p:nvSpPr>
+          <p:cNvPr id="15" name="Text 13"/>
+          <p:cNvSpPr txBox="1"/>
+          <p:nvPr/>
+        </p:nvSpPr>
+        <p:spPr>
+          <a:xfrm>
+            <a:off x="9272016" y="1828800"/>
+            <a:ext cx="2103120" cy="822960"/>
+          </a:xfrm>
+          <a:prstGeom prst="rect">
+            <a:avLst/>
+          </a:prstGeom>
+          <a:noFill/>
+          <a:ln/>
+        </p:spPr>
+        <p:txBody>
+          <a:bodyPr wrap="square" lIns="0" tIns="0" rIns="0" bIns="0" rtlCol="0" anchor="t"/>
+          <a:lstStyle/>
+          <a:p>
+            <a:pPr indent="0" marL="0">
+              <a:buNone/>
+            </a:pPr>
+            <a:r>
+              <a:rPr lang="en-US" sz="2000" b="1" dirty="0">
+                <a:solidFill>
+                  <a:srgbClr val="3FA796"/>
+                </a:solidFill>
+                <a:latin typeface="Cambria" pitchFamily="34" charset="0"/>
+                <a:ea typeface="Cambria" pitchFamily="34" charset="-122"/>
+                <a:cs typeface="Cambria" pitchFamily="34" charset="-120"/>
+              </a:rPr>
+              <a:t>No compliance claim</a:t>
+            </a:r>
+            <a:endParaRPr lang="en-US" sz="2000" dirty="0"/>
+          </a:p>
+        </p:txBody>
+      </p:sp>
+      <p:sp>
+        <p:nvSpPr>
+          <p:cNvPr id="16" name="Text 14"/>
+          <p:cNvSpPr txBox="1"/>
+          <p:nvPr/>
+        </p:nvSpPr>
+        <p:spPr>
+          <a:xfrm>
+            <a:off x="9272016" y="2743200"/>
+            <a:ext cx="2103120" cy="2926080"/>
+          </a:xfrm>
+          <a:prstGeom prst="rect">
+            <a:avLst/>
+          </a:prstGeom>
+          <a:noFill/>
+          <a:ln/>
+        </p:spPr>
+        <p:txBody>
+          <a:bodyPr wrap="square" lIns="0" tIns="0" rIns="0" bIns="0" rtlCol="0" anchor="t"/>
+          <a:lstStyle/>
+          <a:p>
+            <a:pPr indent="0" marL="0">
+              <a:buNone/>
+            </a:pPr>
+            <a:r>
+              <a:rPr lang="en-US" sz="1500" dirty="0">
+                <a:solidFill>
+                  <a:srgbClr val="1F3A33"/>
+                </a:solidFill>
+                <a:latin typeface="Calibri" pitchFamily="34" charset="0"/>
+                <a:ea typeface="Calibri" pitchFamily="34" charset="-122"/>
+                <a:cs typeface="Calibri" pitchFamily="34" charset="-120"/>
+              </a:rPr>
+              <a:t>No ISO 13485 / 14971 / IEC 62304 evidence exists here, so none is claimed. Real validation comes first.</a:t>
+            </a:r>
+            <a:endParaRPr lang="en-US" sz="1500" dirty="0"/>
+          </a:p>
+        </p:txBody>
+      </p:sp>
+    </p:spTree>
+  </p:cSld>
+  <p:clrMapOvr>
+    <a:masterClrMapping/>
+  </p:clrMapOvr>
+</p:sld>
+</file>
+
+<file path=ppt/slides/slide11.xml><?xml version="1.0" encoding="utf-8"?>
+<p:sld xmlns:a="http://schemas.openxmlformats.org/drawingml/2006/main" xmlns:r="http://schemas.openxmlformats.org/officeDocument/2006/relationships" xmlns:p="http://schemas.openxmlformats.org/presentationml/2006/main">
+  <p:cSld name="Slide 11">
+    <p:bg>
+      <p:bgPr>
+        <a:solidFill>
+          <a:srgbClr val="FFFFFF"/>
+        </a:solidFill>
+      </p:bgPr>
+    </p:bg>
+    <p:spTree>
+      <p:nvGrpSpPr>
+        <p:cNvPr id="1" name=""/>
+        <p:cNvGrpSpPr/>
+        <p:nvPr/>
+      </p:nvGrpSpPr>
+      <p:grpSpPr>
+        <a:xfrm>
+          <a:off x="0" y="0"/>
+          <a:ext cx="0" cy="0"/>
+          <a:chOff x="0" y="0"/>
+          <a:chExt cx="0" cy="0"/>
+        </a:xfrm>
+      </p:grpSpPr>
+      <p:sp>
+        <p:nvSpPr>
+          <p:cNvPr id="2" name="Text 0"/>
+          <p:cNvSpPr txBox="1"/>
+          <p:nvPr/>
+        </p:nvSpPr>
+        <p:spPr>
+          <a:xfrm>
+            <a:off x="548640" y="365760"/>
+            <a:ext cx="11064240" cy="822960"/>
+          </a:xfrm>
+          <a:prstGeom prst="rect">
+            <a:avLst/>
+          </a:prstGeom>
+          <a:noFill/>
+          <a:ln/>
+        </p:spPr>
+        <p:txBody>
+          <a:bodyPr wrap="square" lIns="0" tIns="0" rIns="0" bIns="0" rtlCol="0" anchor="ctr"/>
+          <a:lstStyle/>
+          <a:p>
+            <a:pPr indent="0" marL="0">
+              <a:buNone/>
+            </a:pPr>
+            <a:r>
+              <a:rPr lang="en-US" sz="3600" b="1" dirty="0">
+                <a:solidFill>
+                  <a:srgbClr val="1F3A33"/>
+                </a:solidFill>
+                <a:latin typeface="Cambria" pitchFamily="34" charset="0"/>
+                <a:ea typeface="Cambria" pitchFamily="34" charset="-122"/>
+                <a:cs typeface="Cambria" pitchFamily="34" charset="-120"/>
+              </a:rPr>
+              <a:t>Why it matters, and what to be honest about</a:t>
+            </a:r>
+            <a:endParaRPr lang="en-US" sz="3600" dirty="0"/>
+          </a:p>
+        </p:txBody>
+      </p:sp>
+      <p:sp>
+        <p:nvSpPr>
+          <p:cNvPr id="3" name="Text 1"/>
+          <p:cNvSpPr txBox="1"/>
+          <p:nvPr/>
+        </p:nvSpPr>
+        <p:spPr>
+          <a:xfrm>
+            <a:off x="548640" y="6400800"/>
+            <a:ext cx="8229600" cy="274320"/>
+          </a:xfrm>
+          <a:prstGeom prst="rect">
+            <a:avLst/>
+          </a:prstGeom>
+          <a:noFill/>
+          <a:ln/>
+        </p:spPr>
+        <p:txBody>
+          <a:bodyPr wrap="square" lIns="0" tIns="0" rIns="0" bIns="0" rtlCol="0" anchor="ctr"/>
+          <a:lstStyle/>
+          <a:p>
+            <a:pPr indent="0" marL="0">
+              <a:buNone/>
+            </a:pPr>
+            <a:r>
+              <a:rPr lang="en-US" sz="1000" dirty="0">
+                <a:solidFill>
+                  <a:srgbClr val="5C7A70"/>
+                </a:solidFill>
+                <a:latin typeface="Calibri" pitchFamily="34" charset="0"/>
+                <a:ea typeface="Calibri" pitchFamily="34" charset="-122"/>
+                <a:cs typeface="Calibri" pitchFamily="34" charset="-120"/>
+              </a:rPr>
+              <a:t>Sri Japji Kaur Dardi  |  Thapar Institute of Engineering and Technology</a:t>
+            </a:r>
+            <a:endParaRPr lang="en-US" sz="1000" dirty="0"/>
+          </a:p>
+        </p:txBody>
+      </p:sp>
+      <p:sp>
+        <p:nvSpPr>
+          <p:cNvPr id="4" name="Text 2"/>
+          <p:cNvSpPr txBox="1"/>
+          <p:nvPr/>
+        </p:nvSpPr>
+        <p:spPr>
+          <a:xfrm>
+            <a:off x="11064240" y="6400800"/>
+            <a:ext cx="548640" cy="274320"/>
+          </a:xfrm>
+          <a:prstGeom prst="rect">
+            <a:avLst/>
+          </a:prstGeom>
+          <a:noFill/>
+          <a:ln/>
+        </p:spPr>
+        <p:txBody>
+          <a:bodyPr wrap="square" lIns="0" tIns="0" rIns="0" bIns="0" rtlCol="0" anchor="ctr"/>
+          <a:lstStyle/>
+          <a:p>
+            <a:pPr algn="r" indent="0" marL="0">
+              <a:buNone/>
+            </a:pPr>
+            <a:r>
+              <a:rPr lang="en-US" sz="1000" dirty="0">
+                <a:solidFill>
+                  <a:srgbClr val="5C7A70"/>
+                </a:solidFill>
+                <a:latin typeface="Calibri" pitchFamily="34" charset="0"/>
+                <a:ea typeface="Calibri" pitchFamily="34" charset="-122"/>
+                <a:cs typeface="Calibri" pitchFamily="34" charset="-120"/>
+              </a:rPr>
+              <a:t>11</a:t>
+            </a:r>
+            <a:endParaRPr lang="en-US" sz="1000" dirty="0"/>
+          </a:p>
+        </p:txBody>
+      </p:sp>
+      <p:sp>
+        <p:nvSpPr>
+          <p:cNvPr id="5" name="india-card"/>
+          <p:cNvSpPr/>
+          <p:nvPr/>
+        </p:nvSpPr>
+        <p:spPr>
+          <a:xfrm>
+            <a:off x="548640" y="1554480"/>
+            <a:ext cx="5440680" cy="3566160"/>
+          </a:xfrm>
+          <a:prstGeom prst="roundRect">
+            <a:avLst>
+              <a:gd name="adj" fmla="val 3846"/>
+            </a:avLst>
+          </a:prstGeom>
+          <a:solidFill>
+            <a:srgbClr val="EEF7F2"/>
+          </a:solidFill>
+          <a:ln w="12700">
+            <a:solidFill>
+              <a:srgbClr val="EEF7F2"/>
+            </a:solidFill>
+            <a:prstDash val="solid"/>
+          </a:ln>
+          <a:effectLst>
+            <a:outerShdw sx="100000" sy="100000" kx="0" ky="0" algn="bl" rotWithShape="0" blurRad="101600" dist="25400" dir="5400000">
+              <a:srgbClr val="8FB5A6">
+                <a:alpha val="25000"/>
+              </a:srgbClr>
+            </a:outerShdw>
+          </a:effectLst>
+        </p:spPr>
+      </p:sp>
+      <p:sp>
+        <p:nvSpPr>
+          <p:cNvPr id="6" name="Text 4"/>
+          <p:cNvSpPr txBox="1"/>
+          <p:nvPr/>
+        </p:nvSpPr>
+        <p:spPr>
+          <a:xfrm>
+            <a:off x="822960" y="1783080"/>
+            <a:ext cx="4937760" cy="457200"/>
+          </a:xfrm>
+          <a:prstGeom prst="rect">
+            <a:avLst/>
+          </a:prstGeom>
+          <a:noFill/>
+          <a:ln/>
+        </p:spPr>
+        <p:txBody>
+          <a:bodyPr wrap="square" lIns="0" tIns="0" rIns="0" bIns="0" rtlCol="0" anchor="ctr"/>
+          <a:lstStyle/>
+          <a:p>
+            <a:pPr indent="0" marL="0">
+              <a:buNone/>
+            </a:pPr>
+            <a:r>
+              <a:rPr lang="en-US" sz="2400" b="1" dirty="0">
+                <a:solidFill>
+                  <a:srgbClr val="3FA796"/>
+                </a:solidFill>
+                <a:latin typeface="Cambria" pitchFamily="34" charset="0"/>
+                <a:ea typeface="Cambria" pitchFamily="34" charset="-122"/>
+                <a:cs typeface="Cambria" pitchFamily="34" charset="-120"/>
+              </a:rPr>
+              <a:t>Relevance to India</a:t>
+            </a:r>
+            <a:endParaRPr lang="en-US" sz="2400" dirty="0"/>
+          </a:p>
+        </p:txBody>
+      </p:sp>
+      <p:sp>
+        <p:nvSpPr>
+          <p:cNvPr id="7" name="Text 5"/>
+          <p:cNvSpPr txBox="1"/>
+          <p:nvPr/>
+        </p:nvSpPr>
+        <p:spPr>
+          <a:xfrm>
+            <a:off x="822960" y="2423160"/>
+            <a:ext cx="4937760" cy="2468880"/>
+          </a:xfrm>
+          <a:prstGeom prst="rect">
+            <a:avLst/>
+          </a:prstGeom>
+          <a:noFill/>
+          <a:ln/>
+        </p:spPr>
+        <p:txBody>
+          <a:bodyPr wrap="square" lIns="0" tIns="0" rIns="0" bIns="0" rtlCol="0" anchor="t"/>
+          <a:lstStyle/>
+          <a:p>
+            <a:pPr marL="342900" indent="-342900">
+              <a:spcAft>
+                <a:spcPts val="1000"/>
+              </a:spcAft>
+              <a:buSzPct val="100000"/>
+              <a:buChar char="•"/>
+            </a:pPr>
+            <a:r>
+              <a:rPr lang="en-US" sz="1800" dirty="0">
+                <a:solidFill>
+                  <a:srgbClr val="1F3A33"/>
+                </a:solidFill>
+                <a:latin typeface="Calibri" pitchFamily="34" charset="0"/>
+                <a:ea typeface="Calibri" pitchFamily="34" charset="-122"/>
+                <a:cs typeface="Calibri" pitchFamily="34" charset="-120"/>
+              </a:rPr>
+              <a:t>Huge and growing T2D burden</a:t>
+            </a:r>
+            <a:endParaRPr lang="en-US" sz="1800" dirty="0"/>
+          </a:p>
+          <a:p>
+            <a:pPr marL="342900" indent="-342900">
+              <a:spcAft>
+                <a:spcPts val="1000"/>
+              </a:spcAft>
+              <a:buSzPct val="100000"/>
+              <a:buChar char="•"/>
+            </a:pPr>
+            <a:r>
+              <a:rPr lang="en-US" sz="1800" dirty="0">
+                <a:solidFill>
+                  <a:srgbClr val="1F3A33"/>
+                </a:solidFill>
+                <a:latin typeface="Calibri" pitchFamily="34" charset="0"/>
+                <a:ea typeface="Calibri" pitchFamily="34" charset="-122"/>
+                <a:cs typeface="Calibri" pitchFamily="34" charset="-120"/>
+              </a:rPr>
+              <a:t>Carbohydrate-heavy diets</a:t>
+            </a:r>
+            <a:endParaRPr lang="en-US" sz="1800" dirty="0"/>
+          </a:p>
+          <a:p>
+            <a:pPr marL="342900" indent="-342900">
+              <a:spcAft>
+                <a:spcPts val="1000"/>
+              </a:spcAft>
+              <a:buSzPct val="100000"/>
+              <a:buChar char="•"/>
+            </a:pPr>
+            <a:r>
+              <a:rPr lang="en-US" sz="1800" dirty="0">
+                <a:solidFill>
+                  <a:srgbClr val="1F3A33"/>
+                </a:solidFill>
+                <a:latin typeface="Calibri" pitchFamily="34" charset="0"/>
+                <a:ea typeface="Calibri" pitchFamily="34" charset="-122"/>
+                <a:cs typeface="Calibri" pitchFamily="34" charset="-120"/>
+              </a:rPr>
+              <a:t>Low-cost wearables and CGM are spreading</a:t>
+            </a:r>
+            <a:endParaRPr lang="en-US" sz="1800" dirty="0"/>
+          </a:p>
+          <a:p>
+            <a:pPr marL="342900" indent="-342900">
+              <a:spcAft>
+                <a:spcPts val="1000"/>
+              </a:spcAft>
+              <a:buSzPct val="100000"/>
+              <a:buChar char="•"/>
+            </a:pPr>
+            <a:r>
+              <a:rPr lang="en-US" sz="1800" dirty="0">
+                <a:solidFill>
+                  <a:srgbClr val="1F3A33"/>
+                </a:solidFill>
+                <a:latin typeface="Calibri" pitchFamily="34" charset="0"/>
+                <a:ea typeface="Calibri" pitchFamily="34" charset="-122"/>
+                <a:cs typeface="Calibri" pitchFamily="34" charset="-120"/>
+              </a:rPr>
+              <a:t>Proactive alerts support earlier intervention</a:t>
+            </a:r>
+            <a:endParaRPr lang="en-US" sz="1800" dirty="0"/>
+          </a:p>
+        </p:txBody>
+      </p:sp>
+      <p:sp>
+        <p:nvSpPr>
+          <p:cNvPr id="8" name="limits-card"/>
+          <p:cNvSpPr/>
+          <p:nvPr/>
+        </p:nvSpPr>
+        <p:spPr>
+          <a:xfrm>
+            <a:off x="6199632" y="1554480"/>
+            <a:ext cx="5440680" cy="3566160"/>
+          </a:xfrm>
+          <a:prstGeom prst="roundRect">
+            <a:avLst>
+              <a:gd name="adj" fmla="val 3846"/>
+            </a:avLst>
+          </a:prstGeom>
+          <a:solidFill>
+            <a:srgbClr val="FDEBE3"/>
+          </a:solidFill>
+          <a:ln w="12700">
+            <a:solidFill>
+              <a:srgbClr val="FDEBE3"/>
+            </a:solidFill>
+            <a:prstDash val="solid"/>
+          </a:ln>
+          <a:effectLst>
+            <a:outerShdw sx="100000" sy="100000" kx="0" ky="0" algn="bl" rotWithShape="0" blurRad="101600" dist="25400" dir="5400000">
+              <a:srgbClr val="8FB5A6">
+                <a:alpha val="25000"/>
+              </a:srgbClr>
+            </a:outerShdw>
+          </a:effectLst>
+        </p:spPr>
+      </p:sp>
+      <p:sp>
+        <p:nvSpPr>
+          <p:cNvPr id="9" name="Text 7"/>
+          <p:cNvSpPr txBox="1"/>
+          <p:nvPr/>
+        </p:nvSpPr>
+        <p:spPr>
+          <a:xfrm>
+            <a:off x="6473952" y="1783080"/>
+            <a:ext cx="4937760" cy="457200"/>
+          </a:xfrm>
+          <a:prstGeom prst="rect">
+            <a:avLst/>
+          </a:prstGeom>
+          <a:noFill/>
+          <a:ln/>
+        </p:spPr>
+        <p:txBody>
+          <a:bodyPr wrap="square" lIns="0" tIns="0" rIns="0" bIns="0" rtlCol="0" anchor="ctr"/>
+          <a:lstStyle/>
+          <a:p>
+            <a:pPr indent="0" marL="0">
+              <a:buNone/>
+            </a:pPr>
+            <a:r>
+              <a:rPr lang="en-US" sz="2400" b="1" dirty="0">
+                <a:solidFill>
+                  <a:srgbClr val="C0603F"/>
+                </a:solidFill>
+                <a:latin typeface="Cambria" pitchFamily="34" charset="0"/>
+                <a:ea typeface="Cambria" pitchFamily="34" charset="-122"/>
+                <a:cs typeface="Cambria" pitchFamily="34" charset="-120"/>
+              </a:rPr>
+              <a:t>Limitations</a:t>
+            </a:r>
+            <a:endParaRPr lang="en-US" sz="2400" dirty="0"/>
+          </a:p>
+        </p:txBody>
+      </p:sp>
+      <p:sp>
+        <p:nvSpPr>
+          <p:cNvPr id="10" name="Text 8"/>
+          <p:cNvSpPr txBox="1"/>
+          <p:nvPr/>
+        </p:nvSpPr>
+        <p:spPr>
+          <a:xfrm>
+            <a:off x="6473952" y="2423160"/>
+            <a:ext cx="4937760" cy="2468880"/>
+          </a:xfrm>
+          <a:prstGeom prst="rect">
+            <a:avLst/>
+          </a:prstGeom>
+          <a:noFill/>
+          <a:ln/>
+        </p:spPr>
+        <p:txBody>
+          <a:bodyPr wrap="square" lIns="0" tIns="0" rIns="0" bIns="0" rtlCol="0" anchor="t"/>
+          <a:lstStyle/>
+          <a:p>
+            <a:pPr marL="342900" indent="-342900">
+              <a:spcAft>
+                <a:spcPts val="1000"/>
+              </a:spcAft>
+              <a:buSzPct val="100000"/>
+              <a:buChar char="•"/>
+            </a:pPr>
+            <a:r>
+              <a:rPr lang="en-US" sz="1800" dirty="0">
+                <a:solidFill>
+                  <a:srgbClr val="1F3A33"/>
+                </a:solidFill>
+                <a:latin typeface="Calibri" pitchFamily="34" charset="0"/>
+                <a:ea typeface="Calibri" pitchFamily="34" charset="-122"/>
+                <a:cs typeface="Calibri" pitchFamily="34" charset="-120"/>
+              </a:rPr>
+              <a:t>Synthetic data: results are an upper bound</a:t>
+            </a:r>
+            <a:endParaRPr lang="en-US" sz="1800" dirty="0"/>
+          </a:p>
+          <a:p>
+            <a:pPr marL="342900" indent="-342900">
+              <a:spcAft>
+                <a:spcPts val="1000"/>
+              </a:spcAft>
+              <a:buSzPct val="100000"/>
+              <a:buChar char="•"/>
+            </a:pPr>
+            <a:r>
+              <a:rPr lang="en-US" sz="1800" dirty="0">
+                <a:solidFill>
+                  <a:srgbClr val="1F3A33"/>
+                </a:solidFill>
+                <a:latin typeface="Calibri" pitchFamily="34" charset="0"/>
+                <a:ea typeface="Calibri" pitchFamily="34" charset="-122"/>
+                <a:cs typeface="Calibri" pitchFamily="34" charset="-120"/>
+              </a:rPr>
+              <a:t>Simulator encodes assumed physiology</a:t>
+            </a:r>
+            <a:endParaRPr lang="en-US" sz="1800" dirty="0"/>
+          </a:p>
+          <a:p>
+            <a:pPr marL="342900" indent="-342900">
+              <a:spcAft>
+                <a:spcPts val="1000"/>
+              </a:spcAft>
+              <a:buSzPct val="100000"/>
+              <a:buChar char="•"/>
+            </a:pPr>
+            <a:r>
+              <a:rPr lang="en-US" sz="1800" dirty="0">
+                <a:solidFill>
+                  <a:srgbClr val="1F3A33"/>
+                </a:solidFill>
+                <a:latin typeface="Calibri" pitchFamily="34" charset="0"/>
+                <a:ea typeface="Calibri" pitchFamily="34" charset="-122"/>
+                <a:cs typeface="Calibri" pitchFamily="34" charset="-120"/>
+              </a:rPr>
+              <a:t>Lows depend on a simulated drug effect</a:t>
+            </a:r>
+            <a:endParaRPr lang="en-US" sz="1800" dirty="0"/>
+          </a:p>
+          <a:p>
+            <a:pPr marL="342900" indent="-342900">
+              <a:spcAft>
+                <a:spcPts val="1000"/>
+              </a:spcAft>
+              <a:buSzPct val="100000"/>
+              <a:buChar char="•"/>
+            </a:pPr>
+            <a:r>
+              <a:rPr lang="en-US" sz="1800" dirty="0">
+                <a:solidFill>
+                  <a:srgbClr val="1F3A33"/>
+                </a:solidFill>
+                <a:latin typeface="Calibri" pitchFamily="34" charset="0"/>
+                <a:ea typeface="Calibri" pitchFamily="34" charset="-122"/>
+                <a:cs typeface="Calibri" pitchFamily="34" charset="-120"/>
+              </a:rPr>
+              <a:t>Not a medical device; not clinically validated</a:t>
+            </a:r>
+            <a:endParaRPr lang="en-US" sz="1800" dirty="0"/>
+          </a:p>
+        </p:txBody>
+      </p:sp>
+    </p:spTree>
+  </p:cSld>
+  <p:clrMapOvr>
+    <a:masterClrMapping/>
+  </p:clrMapOvr>
+</p:sld>
+</file>
+
+<file path=ppt/slides/slide12.xml><?xml version="1.0" encoding="utf-8"?>
+<p:sld xmlns:a="http://schemas.openxmlformats.org/drawingml/2006/main" xmlns:r="http://schemas.openxmlformats.org/officeDocument/2006/relationships" xmlns:p="http://schemas.openxmlformats.org/presentationml/2006/main">
+  <p:cSld name="Slide 12">
+    <p:bg>
+      <p:bgPr>
+        <a:solidFill>
+          <a:srgbClr val="FFFFFF"/>
+        </a:solidFill>
+      </p:bgPr>
+    </p:bg>
+    <p:spTree>
+      <p:nvGrpSpPr>
+        <p:cNvPr id="1" name=""/>
+        <p:cNvGrpSpPr/>
+        <p:nvPr/>
+      </p:nvGrpSpPr>
+      <p:grpSpPr>
+        <a:xfrm>
+          <a:off x="0" y="0"/>
+          <a:ext cx="0" cy="0"/>
+          <a:chOff x="0" y="0"/>
+          <a:chExt cx="0" cy="0"/>
+        </a:xfrm>
+      </p:grpSpPr>
+      <p:sp>
+        <p:nvSpPr>
+          <p:cNvPr id="2" name="Text 0"/>
+          <p:cNvSpPr txBox="1"/>
+          <p:nvPr/>
+        </p:nvSpPr>
+        <p:spPr>
+          <a:xfrm>
+            <a:off x="548640" y="365760"/>
+            <a:ext cx="11064240" cy="822960"/>
+          </a:xfrm>
+          <a:prstGeom prst="rect">
+            <a:avLst/>
+          </a:prstGeom>
+          <a:noFill/>
+          <a:ln/>
+        </p:spPr>
+        <p:txBody>
+          <a:bodyPr wrap="square" lIns="0" tIns="0" rIns="0" bIns="0" rtlCol="0" anchor="ctr"/>
+          <a:lstStyle/>
+          <a:p>
+            <a:pPr indent="0" marL="0">
+              <a:buNone/>
+            </a:pPr>
+            <a:r>
+              <a:rPr lang="en-US" sz="3600" b="1" dirty="0">
+                <a:solidFill>
+                  <a:srgbClr val="1F3A33"/>
+                </a:solidFill>
+                <a:latin typeface="Cambria" pitchFamily="34" charset="0"/>
+                <a:ea typeface="Cambria" pitchFamily="34" charset="-122"/>
+                <a:cs typeface="Cambria" pitchFamily="34" charset="-120"/>
+              </a:rPr>
+              <a:t>Next steps</a:t>
+            </a:r>
+            <a:endParaRPr lang="en-US" sz="3600" dirty="0"/>
+          </a:p>
+        </p:txBody>
+      </p:sp>
+      <p:sp>
+        <p:nvSpPr>
+          <p:cNvPr id="3" name="Text 1"/>
+          <p:cNvSpPr txBox="1"/>
+          <p:nvPr/>
+        </p:nvSpPr>
+        <p:spPr>
+          <a:xfrm>
+            <a:off x="548640" y="6400800"/>
+            <a:ext cx="8229600" cy="274320"/>
+          </a:xfrm>
+          <a:prstGeom prst="rect">
+            <a:avLst/>
+          </a:prstGeom>
+          <a:noFill/>
+          <a:ln/>
+        </p:spPr>
+        <p:txBody>
+          <a:bodyPr wrap="square" lIns="0" tIns="0" rIns="0" bIns="0" rtlCol="0" anchor="ctr"/>
+          <a:lstStyle/>
+          <a:p>
+            <a:pPr indent="0" marL="0">
+              <a:buNone/>
+            </a:pPr>
+            <a:r>
+              <a:rPr lang="en-US" sz="1000" dirty="0">
+                <a:solidFill>
+                  <a:srgbClr val="5C7A70"/>
+                </a:solidFill>
+                <a:latin typeface="Calibri" pitchFamily="34" charset="0"/>
+                <a:ea typeface="Calibri" pitchFamily="34" charset="-122"/>
+                <a:cs typeface="Calibri" pitchFamily="34" charset="-120"/>
+              </a:rPr>
+              <a:t>Sri Japji Kaur Dardi  |  Thapar Institute of Engineering and Technology</a:t>
+            </a:r>
+            <a:endParaRPr lang="en-US" sz="1000" dirty="0"/>
+          </a:p>
+        </p:txBody>
+      </p:sp>
+      <p:sp>
+        <p:nvSpPr>
+          <p:cNvPr id="4" name="Text 2"/>
+          <p:cNvSpPr txBox="1"/>
+          <p:nvPr/>
+        </p:nvSpPr>
+        <p:spPr>
+          <a:xfrm>
+            <a:off x="11064240" y="6400800"/>
+            <a:ext cx="548640" cy="274320"/>
+          </a:xfrm>
+          <a:prstGeom prst="rect">
+            <a:avLst/>
+          </a:prstGeom>
+          <a:noFill/>
+          <a:ln/>
+        </p:spPr>
+        <p:txBody>
+          <a:bodyPr wrap="square" lIns="0" tIns="0" rIns="0" bIns="0" rtlCol="0" anchor="ctr"/>
+          <a:lstStyle/>
+          <a:p>
+            <a:pPr algn="r" indent="0" marL="0">
+              <a:buNone/>
+            </a:pPr>
+            <a:r>
+              <a:rPr lang="en-US" sz="1000" dirty="0">
+                <a:solidFill>
+                  <a:srgbClr val="5C7A70"/>
+                </a:solidFill>
+                <a:latin typeface="Calibri" pitchFamily="34" charset="0"/>
+                <a:ea typeface="Calibri" pitchFamily="34" charset="-122"/>
+                <a:cs typeface="Calibri" pitchFamily="34" charset="-120"/>
+              </a:rPr>
+              <a:t>12</a:t>
+            </a:r>
+            <a:endParaRPr lang="en-US" sz="1000" dirty="0"/>
+          </a:p>
+        </p:txBody>
+      </p:sp>
+      <p:sp>
+        <p:nvSpPr>
+          <p:cNvPr id="5" name="next-1"/>
+          <p:cNvSpPr/>
+          <p:nvPr/>
+        </p:nvSpPr>
+        <p:spPr>
+          <a:xfrm>
+            <a:off x="548640" y="1737360"/>
+            <a:ext cx="2606040" cy="3840480"/>
+          </a:xfrm>
+          <a:prstGeom prst="roundRect">
+            <a:avLst>
+              <a:gd name="adj" fmla="val 5263"/>
+            </a:avLst>
+          </a:prstGeom>
+          <a:solidFill>
+            <a:srgbClr val="EEF7F2"/>
+          </a:solidFill>
+          <a:ln w="12700">
+            <a:solidFill>
+              <a:srgbClr val="EEF7F2"/>
+            </a:solidFill>
+            <a:prstDash val="solid"/>
+          </a:ln>
+          <a:effectLst>
+            <a:outerShdw sx="100000" sy="100000" kx="0" ky="0" algn="bl" rotWithShape="0" blurRad="101600" dist="25400" dir="5400000">
+              <a:srgbClr val="8FB5A6">
+                <a:alpha val="25000"/>
+              </a:srgbClr>
+            </a:outerShdw>
+          </a:effectLst>
+        </p:spPr>
+      </p:sp>
+      <p:sp>
+        <p:nvSpPr>
           <p:cNvPr id="6" name="num-1"/>
           <p:cNvSpPr/>
           <p:nvPr/>
@@ -3320,7 +4906,7 @@
                 <a:ea typeface="Calibri" pitchFamily="34" charset="-122"/>
                 <a:cs typeface="Calibri" pitchFamily="34" charset="-120"/>
               </a:rPr>
-              <a:t>Open, de-identified CGM datasets and Synthea / MIMIC-IV EHR</a:t>
+              <a:t>ShanghaiT2DM test script included; then Indian cohorts</a:t>
             </a:r>
             <a:endParaRPr lang="en-US" sz="1500" dirty="0"/>
           </a:p>
@@ -5833,7 +7419,7 @@
                 <a:ea typeface="Calibri" pitchFamily="34" charset="-122"/>
                 <a:cs typeface="Calibri" pitchFamily="34" charset="-120"/>
               </a:rPr>
-              <a:t>Post-meal walking lowers the spike; short sleep raises it</a:t>
+              <a:t>Walking lowers spikes; short sleep raises them; drug dose + skipped meals cause lows</a:t>
             </a:r>
             <a:endParaRPr lang="en-US" sz="1600" dirty="0"/>
           </a:p>
@@ -5854,7 +7440,7 @@
                 <a:ea typeface="Calibri" pitchFamily="34" charset="-122"/>
                 <a:cs typeface="Calibri" pitchFamily="34" charset="-120"/>
               </a:rPr>
-              <a:t>No real patient data: DPDP Act and HIPAA safe</a:t>
+              <a:t>No real patient data used, so no personal-data exposure</a:t>
             </a:r>
             <a:endParaRPr lang="en-US" sz="1600" dirty="0"/>
           </a:p>
@@ -6526,7 +8112,7 @@
                 <a:ea typeface="Calibri" pitchFamily="34" charset="-122"/>
                 <a:cs typeface="Calibri" pitchFamily="34" charset="-120"/>
               </a:rPr>
-              <a:t>gradient boosting, P(glucose &gt; 180 mg/dL in 2 h)</a:t>
+              <a:t>two models: P(glucose &gt; 180) and P(glucose &lt; 70) in 2 h</a:t>
             </a:r>
             <a:endParaRPr lang="en-US" sz="1400" dirty="0"/>
           </a:p>
@@ -6663,7 +8249,7 @@
                 <a:ea typeface="Calibri" pitchFamily="34" charset="-122"/>
                 <a:cs typeface="Calibri" pitchFamily="34" charset="-120"/>
               </a:rPr>
-              <a:t>EHR card, glucose trace, risk alerts</a:t>
+              <a:t>EHR card, glucose trace, high + low alerts, SHAP</a:t>
             </a:r>
             <a:endParaRPr lang="en-US" sz="1400" dirty="0"/>
           </a:p>
@@ -6814,7 +8400,7 @@
                 <a:ea typeface="Calibri" pitchFamily="34" charset="-122"/>
                 <a:cs typeface="Calibri" pitchFamily="34" charset="-120"/>
               </a:rPr>
-              <a:t>Evaluation: ablation of CGM only vs + wearable vs + EHR, with ROC-AUC, PR-AUC and permutation importance</a:t>
+              <a:t>Evaluation: ablation of CGM only vs + wearable vs + EHR, with ROC-AUC, PR-AUC and SHAP</a:t>
             </a:r>
             <a:endParaRPr lang="en-US" sz="1600" dirty="0"/>
           </a:p>
@@ -7195,7 +8781,7 @@
       </p:sp>
       <p:sp>
         <p:nvSpPr>
-          <p:cNvPr id="11" name="stat-11"/>
+          <p:cNvPr id="11" name="stat-12"/>
           <p:cNvSpPr/>
           <p:nvPr/>
         </p:nvSpPr>
@@ -7260,7 +8846,7 @@
                 <a:ea typeface="Cambria" pitchFamily="34" charset="-122"/>
                 <a:cs typeface="Cambria" pitchFamily="34" charset="-120"/>
               </a:rPr>
-              <a:t>11</a:t>
+              <a:t>12</a:t>
             </a:r>
             <a:endParaRPr lang="en-US" sz="4400" dirty="0"/>
           </a:p>
@@ -7411,7 +8997,7 @@
                 <a:ea typeface="Calibri" pitchFamily="34" charset="-122"/>
                 <a:cs typeface="Calibri" pitchFamily="34" charset="-120"/>
               </a:rPr>
-              <a:t>Will glucose exceed 180 mg/dL within the next 2 hours, given it is at or below 180 now? Gradient boosting classifier, trained on 75% of patients and tested on unseen 25% (no leakage).</a:t>
+              <a:t>Two gradient boosting models: will glucose go above 180 mg/dL, or below 70 mg/dL, within the next 2 hours? Trained on 75% of patients, tested on unseen 25% (no leakage).</a:t>
             </a:r>
             <a:endParaRPr lang="en-US" sz="1800" dirty="0"/>
           </a:p>
@@ -7482,7 +9068,7 @@
                 <a:ea typeface="Cambria" pitchFamily="34" charset="-122"/>
                 <a:cs typeface="Cambria" pitchFamily="34" charset="-120"/>
               </a:rPr>
-              <a:t>Fusing both streams wins</a:t>
+              <a:t>Fusing both streams wins, for highs and lows</a:t>
             </a:r>
             <a:endParaRPr lang="en-US" sz="3600" dirty="0"/>
           </a:p>
@@ -7618,7 +9204,7 @@
       </p:graphicFrame>
       <p:sp>
         <p:nvSpPr>
-          <p:cNvPr id="7" name="stat-0.958"/>
+          <p:cNvPr id="7" name="stat-0.947"/>
           <p:cNvSpPr/>
           <p:nvPr/>
         </p:nvSpPr>
@@ -7683,7 +9269,7 @@
                 <a:ea typeface="Cambria" pitchFamily="34" charset="-122"/>
                 <a:cs typeface="Cambria" pitchFamily="34" charset="-120"/>
               </a:rPr>
-              <a:t>0.958</a:t>
+              <a:t>0.947</a:t>
             </a:r>
             <a:endParaRPr lang="en-US" sz="4400" dirty="0"/>
           </a:p>
@@ -7722,7 +9308,7 @@
                 <a:ea typeface="Calibri" pitchFamily="34" charset="-122"/>
                 <a:cs typeface="Calibri" pitchFamily="34" charset="-120"/>
               </a:rPr>
-              <a:t>ROC-AUC, full twin</a:t>
+              <a:t>ROC-AUC, high-glucose twin</a:t>
             </a:r>
             <a:endParaRPr lang="en-US" sz="1500" dirty="0"/>
           </a:p>
@@ -7730,18 +9316,18 @@
       </p:sp>
       <p:sp>
         <p:nvSpPr>
-          <p:cNvPr id="10" name="stat-0.79"/>
+          <p:cNvPr id="10" name="stat-0.981"/>
           <p:cNvSpPr/>
           <p:nvPr/>
         </p:nvSpPr>
         <p:spPr>
           <a:xfrm>
             <a:off x="7863840" y="3520440"/>
-            <a:ext cx="1783080" cy="1828800"/>
+            <a:ext cx="3776472" cy="1828800"/>
           </a:xfrm>
           <a:prstGeom prst="roundRect">
             <a:avLst>
-              <a:gd name="adj" fmla="val 7692"/>
+              <a:gd name="adj" fmla="val 7500"/>
             </a:avLst>
           </a:prstGeom>
           <a:solidFill>
@@ -7771,7 +9357,7 @@
         <p:spPr>
           <a:xfrm>
             <a:off x="8138160" y="3749040"/>
-            <a:ext cx="1234440" cy="822960"/>
+            <a:ext cx="3227832" cy="822960"/>
           </a:xfrm>
           <a:prstGeom prst="rect">
             <a:avLst/>
@@ -7795,7 +9381,7 @@
                 <a:ea typeface="Cambria" pitchFamily="34" charset="-122"/>
                 <a:cs typeface="Cambria" pitchFamily="34" charset="-120"/>
               </a:rPr>
-              <a:t>0.79</a:t>
+              <a:t>0.981</a:t>
             </a:r>
             <a:endParaRPr lang="en-US" sz="4400" dirty="0"/>
           </a:p>
@@ -7810,7 +9396,7 @@
         <p:spPr>
           <a:xfrm>
             <a:off x="8138160" y="4572000"/>
-            <a:ext cx="1234440" cy="640080"/>
+            <a:ext cx="3227832" cy="640080"/>
           </a:xfrm>
           <a:prstGeom prst="rect">
             <a:avLst/>
@@ -7834,7 +9420,7 @@
                 <a:ea typeface="Calibri" pitchFamily="34" charset="-122"/>
                 <a:cs typeface="Calibri" pitchFamily="34" charset="-120"/>
               </a:rPr>
-              <a:t>precision</a:t>
+              <a:t>ROC-AUC, low-glucose twin</a:t>
             </a:r>
             <a:endParaRPr lang="en-US" sz="1500" dirty="0"/>
           </a:p>
@@ -7842,152 +9428,40 @@
       </p:sp>
       <p:sp>
         <p:nvSpPr>
-          <p:cNvPr id="13" name="stat-0.71"/>
-          <p:cNvSpPr/>
-          <p:nvPr/>
-        </p:nvSpPr>
-        <p:spPr>
-          <a:xfrm>
-            <a:off x="9857232" y="3520440"/>
-            <a:ext cx="1783080" cy="1828800"/>
-          </a:xfrm>
-          <a:prstGeom prst="roundRect">
-            <a:avLst>
-              <a:gd name="adj" fmla="val 7692"/>
-            </a:avLst>
-          </a:prstGeom>
-          <a:solidFill>
-            <a:srgbClr val="E4F1FA"/>
-          </a:solidFill>
-          <a:ln w="12700">
-            <a:solidFill>
-              <a:srgbClr val="E4F1FA"/>
-            </a:solidFill>
-            <a:prstDash val="solid"/>
-          </a:ln>
-          <a:effectLst>
-            <a:outerShdw sx="100000" sy="100000" kx="0" ky="0" algn="bl" rotWithShape="0" blurRad="101600" dist="25400" dir="5400000">
-              <a:srgbClr val="8FB5A6">
-                <a:alpha val="25000"/>
-              </a:srgbClr>
-            </a:outerShdw>
-          </a:effectLst>
-        </p:spPr>
-      </p:sp>
-      <p:sp>
-        <p:nvSpPr>
-          <p:cNvPr id="14" name="Text 11"/>
-          <p:cNvSpPr txBox="1"/>
-          <p:nvPr/>
-        </p:nvSpPr>
-        <p:spPr>
-          <a:xfrm>
-            <a:off x="10131552" y="3749040"/>
-            <a:ext cx="1234440" cy="822960"/>
-          </a:xfrm>
-          <a:prstGeom prst="rect">
-            <a:avLst/>
-          </a:prstGeom>
-          <a:noFill/>
-          <a:ln/>
-        </p:spPr>
-        <p:txBody>
-          <a:bodyPr wrap="square" lIns="0" tIns="0" rIns="0" bIns="0" rtlCol="0" anchor="ctr"/>
+          <p:cNvPr id="13" name="Text 10"/>
+          <p:cNvSpPr txBox="1"/>
+          <p:nvPr/>
+        </p:nvSpPr>
+        <p:spPr>
+          <a:xfrm>
+            <a:off x="7863840" y="5440680"/>
+            <a:ext cx="3776472" cy="548640"/>
+          </a:xfrm>
+          <a:prstGeom prst="rect">
+            <a:avLst/>
+          </a:prstGeom>
+          <a:noFill/>
+          <a:ln/>
+        </p:spPr>
+        <p:txBody>
+          <a:bodyPr wrap="square" lIns="0" tIns="0" rIns="0" bIns="0" rtlCol="0" anchor="t"/>
           <a:lstStyle/>
           <a:p>
             <a:pPr indent="0" marL="0">
               <a:buNone/>
             </a:pPr>
             <a:r>
-              <a:rPr lang="en-US" sz="4400" b="1" dirty="0">
-                <a:solidFill>
-                  <a:srgbClr val="3C8FC4"/>
-                </a:solidFill>
-                <a:latin typeface="Cambria" pitchFamily="34" charset="0"/>
-                <a:ea typeface="Cambria" pitchFamily="34" charset="-122"/>
-                <a:cs typeface="Cambria" pitchFamily="34" charset="-120"/>
-              </a:rPr>
-              <a:t>0.71</a:t>
-            </a:r>
-            <a:endParaRPr lang="en-US" sz="4400" dirty="0"/>
-          </a:p>
-        </p:txBody>
-      </p:sp>
-      <p:sp>
-        <p:nvSpPr>
-          <p:cNvPr id="15" name="Text 12"/>
-          <p:cNvSpPr txBox="1"/>
-          <p:nvPr/>
-        </p:nvSpPr>
-        <p:spPr>
-          <a:xfrm>
-            <a:off x="10131552" y="4572000"/>
-            <a:ext cx="1234440" cy="640080"/>
-          </a:xfrm>
-          <a:prstGeom prst="rect">
-            <a:avLst/>
-          </a:prstGeom>
-          <a:noFill/>
-          <a:ln/>
-        </p:spPr>
-        <p:txBody>
-          <a:bodyPr wrap="square" lIns="0" tIns="0" rIns="0" bIns="0" rtlCol="0" anchor="t"/>
-          <a:lstStyle/>
-          <a:p>
-            <a:pPr indent="0" marL="0">
-              <a:buNone/>
-            </a:pPr>
-            <a:r>
-              <a:rPr lang="en-US" sz="1500" dirty="0">
-                <a:solidFill>
-                  <a:srgbClr val="1F3A33"/>
+              <a:rPr lang="en-US" sz="1200" i="1" dirty="0">
+                <a:solidFill>
+                  <a:srgbClr val="5C7A70"/>
                 </a:solidFill>
                 <a:latin typeface="Calibri" pitchFamily="34" charset="0"/>
                 <a:ea typeface="Calibri" pitchFamily="34" charset="-122"/>
                 <a:cs typeface="Calibri" pitchFamily="34" charset="-120"/>
               </a:rPr>
-              <a:t>recall</a:t>
-            </a:r>
-            <a:endParaRPr lang="en-US" sz="1500" dirty="0"/>
-          </a:p>
-        </p:txBody>
-      </p:sp>
-      <p:sp>
-        <p:nvSpPr>
-          <p:cNvPr id="16" name="Text 13"/>
-          <p:cNvSpPr txBox="1"/>
-          <p:nvPr/>
-        </p:nvSpPr>
-        <p:spPr>
-          <a:xfrm>
-            <a:off x="7863840" y="5486400"/>
-            <a:ext cx="3776472" cy="457200"/>
-          </a:xfrm>
-          <a:prstGeom prst="rect">
-            <a:avLst/>
-          </a:prstGeom>
-          <a:noFill/>
-          <a:ln/>
-        </p:spPr>
-        <p:txBody>
-          <a:bodyPr wrap="square" lIns="0" tIns="0" rIns="0" bIns="0" rtlCol="0" anchor="t"/>
-          <a:lstStyle/>
-          <a:p>
-            <a:pPr indent="0" marL="0">
-              <a:buNone/>
-            </a:pPr>
-            <a:r>
-              <a:rPr lang="en-US" sz="1400" i="1" dirty="0">
-                <a:solidFill>
-                  <a:srgbClr val="5C7A70"/>
-                </a:solidFill>
-                <a:latin typeface="Calibri" pitchFamily="34" charset="0"/>
-                <a:ea typeface="Calibri" pitchFamily="34" charset="-122"/>
-                <a:cs typeface="Calibri" pitchFamily="34" charset="-120"/>
-              </a:rPr>
-              <a:t>Synthetic data: an upper bound, not clinical evidence</a:t>
-            </a:r>
-            <a:endParaRPr lang="en-US" sz="1400" dirty="0"/>
+              <a:t>Lows are rare (2%): PR-AUC 0.61 vs 0.02 by chance. Synthetic data: an upper bound, not clinical evidence</a:t>
+            </a:r>
+            <a:endParaRPr lang="en-US" sz="1200" dirty="0"/>
           </a:p>
         </p:txBody>
       </p:sp>
@@ -8056,7 +9530,7 @@
                 <a:ea typeface="Cambria" pitchFamily="34" charset="-122"/>
                 <a:cs typeface="Cambria" pitchFamily="34" charset="-120"/>
               </a:rPr>
-              <a:t>Doctor's view of the virtual patient</a:t>
+              <a:t>Why did it alert? SHAP explanations</a:t>
             </a:r>
             <a:endParaRPr lang="en-US" sz="3600" dirty="0"/>
           </a:p>
@@ -8142,18 +9616,18 @@
       </p:sp>
       <p:sp>
         <p:nvSpPr>
-          <p:cNvPr id="5" name="patient-card"/>
+          <p:cNvPr id="5" name="shap-card"/>
           <p:cNvSpPr/>
           <p:nvPr/>
         </p:nvSpPr>
         <p:spPr>
           <a:xfrm>
             <a:off x="548640" y="1463040"/>
-            <a:ext cx="3017520" cy="4480560"/>
+            <a:ext cx="7223760" cy="4480560"/>
           </a:xfrm>
           <a:prstGeom prst="roundRect">
             <a:avLst>
-              <a:gd name="adj" fmla="val 4545"/>
+              <a:gd name="adj" fmla="val 3061"/>
             </a:avLst>
           </a:prstGeom>
           <a:solidFill>
@@ -8174,16 +9648,40 @@
           </a:effectLst>
         </p:spPr>
       </p:sp>
-      <p:sp>
-        <p:nvSpPr>
-          <p:cNvPr id="6" name="Text 4"/>
-          <p:cNvSpPr txBox="1"/>
-          <p:nvPr/>
-        </p:nvSpPr>
-        <p:spPr>
-          <a:xfrm>
-            <a:off x="822960" y="1691640"/>
-            <a:ext cx="2560320" cy="411480"/>
+      <p:pic>
+        <p:nvPicPr>
+          <p:cNvPr id="6" name="shap-global" descr="/home/claude/twin-t2d-v2/docs/shap_global.png">    </p:cNvPr>
+          <p:cNvPicPr>
+            <a:picLocks noChangeAspect="1"/>
+          </p:cNvPicPr>
+          <p:nvPr/>
+        </p:nvPicPr>
+        <p:blipFill>
+          <a:blip r:embed="rId1"/>
+          <a:stretch>
+            <a:fillRect/>
+          </a:stretch>
+        </p:blipFill>
+        <p:spPr>
+          <a:xfrm>
+            <a:off x="685800" y="2011680"/>
+            <a:ext cx="6949440" cy="2779776"/>
+          </a:xfrm>
+          <a:prstGeom prst="rect">
+            <a:avLst/>
+          </a:prstGeom>
+        </p:spPr>
+      </p:pic>
+      <p:sp>
+        <p:nvSpPr>
+          <p:cNvPr id="7" name="Text 4"/>
+          <p:cNvSpPr txBox="1"/>
+          <p:nvPr/>
+        </p:nvSpPr>
+        <p:spPr>
+          <a:xfrm>
+            <a:off x="822960" y="1600200"/>
+            <a:ext cx="6400800" cy="365760"/>
           </a:xfrm>
           <a:prstGeom prst="rect">
             <a:avLst/>
@@ -8199,7 +9697,7 @@
               <a:buNone/>
             </a:pPr>
             <a:r>
-              <a:rPr lang="en-US" sz="2200" b="1" dirty="0">
+              <a:rPr lang="en-US" sz="1800" b="1" dirty="0">
                 <a:solidFill>
                   <a:srgbClr val="3FA796"/>
                 </a:solidFill>
@@ -8207,131 +9705,65 @@
                 <a:ea typeface="Cambria" pitchFamily="34" charset="-122"/>
                 <a:cs typeface="Cambria" pitchFamily="34" charset="-120"/>
               </a:rPr>
-              <a:t>Patient #3</a:t>
-            </a:r>
-            <a:endParaRPr lang="en-US" sz="2200" dirty="0"/>
-          </a:p>
-        </p:txBody>
-      </p:sp>
-      <p:sp>
-        <p:nvSpPr>
-          <p:cNvPr id="7" name="Text 5"/>
-          <p:cNvSpPr txBox="1"/>
-          <p:nvPr/>
-        </p:nvSpPr>
-        <p:spPr>
-          <a:xfrm>
-            <a:off x="822960" y="2240280"/>
-            <a:ext cx="2468880" cy="2011680"/>
-          </a:xfrm>
-          <a:prstGeom prst="rect">
-            <a:avLst/>
-          </a:prstGeom>
-          <a:noFill/>
-          <a:ln/>
-        </p:spPr>
-        <p:txBody>
-          <a:bodyPr wrap="square" lIns="0" tIns="0" rIns="0" bIns="0" rtlCol="0" anchor="t"/>
+              <a:t>Global view: which features matter most</a:t>
+            </a:r>
+            <a:endParaRPr lang="en-US" sz="1800" dirty="0"/>
+          </a:p>
+        </p:txBody>
+      </p:sp>
+      <p:sp>
+        <p:nvSpPr>
+          <p:cNvPr id="8" name="Text 5"/>
+          <p:cNvSpPr txBox="1"/>
+          <p:nvPr/>
+        </p:nvSpPr>
+        <p:spPr>
+          <a:xfrm>
+            <a:off x="822960" y="4937760"/>
+            <a:ext cx="6400800" cy="365760"/>
+          </a:xfrm>
+          <a:prstGeom prst="rect">
+            <a:avLst/>
+          </a:prstGeom>
+          <a:noFill/>
+          <a:ln/>
+        </p:spPr>
+        <p:txBody>
+          <a:bodyPr wrap="square" lIns="0" tIns="0" rIns="0" bIns="0" rtlCol="0" anchor="ctr"/>
           <a:lstStyle/>
           <a:p>
             <a:pPr indent="0" marL="0">
               <a:buNone/>
             </a:pPr>
             <a:r>
-              <a:rPr lang="en-US" sz="1600" dirty="0">
-                <a:solidFill>
-                  <a:srgbClr val="1F3A33"/>
+              <a:rPr lang="en-US" sz="1400" i="1" dirty="0">
+                <a:solidFill>
+                  <a:srgbClr val="5C7A70"/>
                 </a:solidFill>
                 <a:latin typeface="Calibri" pitchFamily="34" charset="0"/>
                 <a:ea typeface="Calibri" pitchFamily="34" charset="-122"/>
                 <a:cs typeface="Calibri" pitchFamily="34" charset="-120"/>
               </a:rPr>
-              <a:t>EHR card: age, BMI, HbA1c, eGFR, medication, genetic risk, with live glucose, sleep and steps</a:t>
-            </a:r>
-            <a:endParaRPr lang="en-US" sz="1600" dirty="0"/>
-          </a:p>
-        </p:txBody>
-      </p:sp>
-      <p:sp>
-        <p:nvSpPr>
-          <p:cNvPr id="8" name="alert-pill"/>
+              <a:t>Left: high model. Right: low model.</a:t>
+            </a:r>
+            <a:endParaRPr lang="en-US" sz="1400" dirty="0"/>
+          </a:p>
+        </p:txBody>
+      </p:sp>
+      <p:sp>
+        <p:nvSpPr>
+          <p:cNvPr id="9" name="shap-explain"/>
           <p:cNvSpPr/>
           <p:nvPr/>
         </p:nvSpPr>
         <p:spPr>
           <a:xfrm>
-            <a:off x="822960" y="4572000"/>
-            <a:ext cx="2468880" cy="1005840"/>
+            <a:off x="8046720" y="1463040"/>
+            <a:ext cx="3593592" cy="4480560"/>
           </a:xfrm>
           <a:prstGeom prst="roundRect">
             <a:avLst>
-              <a:gd name="adj" fmla="val 10909"/>
-            </a:avLst>
-          </a:prstGeom>
-          <a:solidFill>
-            <a:srgbClr val="FDEBE3"/>
-          </a:solidFill>
-          <a:ln w="12700">
-            <a:solidFill>
-              <a:srgbClr val="FDEBE3"/>
-            </a:solidFill>
-            <a:prstDash val="solid"/>
-          </a:ln>
-        </p:spPr>
-      </p:sp>
-      <p:sp>
-        <p:nvSpPr>
-          <p:cNvPr id="9" name="Text 7"/>
-          <p:cNvSpPr txBox="1"/>
-          <p:nvPr/>
-        </p:nvSpPr>
-        <p:spPr>
-          <a:xfrm>
-            <a:off x="960120" y="4617720"/>
-            <a:ext cx="2194560" cy="914400"/>
-          </a:xfrm>
-          <a:prstGeom prst="rect">
-            <a:avLst/>
-          </a:prstGeom>
-          <a:noFill/>
-          <a:ln/>
-        </p:spPr>
-        <p:txBody>
-          <a:bodyPr wrap="square" lIns="0" tIns="0" rIns="0" bIns="0" rtlCol="0" anchor="ctr"/>
-          <a:lstStyle/>
-          <a:p>
-            <a:pPr indent="0" marL="0">
-              <a:buNone/>
-            </a:pPr>
-            <a:r>
-              <a:rPr lang="en-US" sz="1400" b="1" dirty="0">
-                <a:solidFill>
-                  <a:srgbClr val="9C4A2F"/>
-                </a:solidFill>
-                <a:latin typeface="Calibri" pitchFamily="34" charset="0"/>
-                <a:ea typeface="Calibri" pitchFamily="34" charset="-122"/>
-                <a:cs typeface="Calibri" pitchFamily="34" charset="-120"/>
-              </a:rPr>
-              <a:t>Alert when 2 h risk passes the chosen threshold</a:t>
-            </a:r>
-            <a:endParaRPr lang="en-US" sz="1400" dirty="0"/>
-          </a:p>
-        </p:txBody>
-      </p:sp>
-      <p:sp>
-        <p:nvSpPr>
-          <p:cNvPr id="10" name="glucose-card"/>
-          <p:cNvSpPr/>
-          <p:nvPr/>
-        </p:nvSpPr>
-        <p:spPr>
-          <a:xfrm>
-            <a:off x="3840480" y="1463040"/>
-            <a:ext cx="7799832" cy="2834640"/>
-          </a:xfrm>
-          <a:prstGeom prst="roundRect">
-            <a:avLst>
-              <a:gd name="adj" fmla="val 4839"/>
+              <a:gd name="adj" fmla="val 3817"/>
             </a:avLst>
           </a:prstGeom>
           <a:solidFill>
@@ -8352,66 +9784,16 @@
           </a:effectLst>
         </p:spPr>
       </p:sp>
-      <p:graphicFrame>
-        <p:nvGraphicFramePr>
-          <p:cNvPr id="11" name="Chart 0" descr=""/>
-          <p:cNvGraphicFramePr/>
-          <p:nvPr/>
-        </p:nvGraphicFramePr>
-        <p:xfrm>
-          <a:off x="3977640" y="1554480"/>
-          <a:ext cx="7498080" cy="2651760"/>
-        </p:xfrm>
-        <a:graphic xmlns:a="http://schemas.openxmlformats.org/drawingml/2006/main">
-          <a:graphicData uri="http://schemas.openxmlformats.org/drawingml/2006/chart">
-            <c:chart xmlns:c="http://schemas.openxmlformats.org/drawingml/2006/chart" r:id="rId1"/>
-          </a:graphicData>
-        </a:graphic>
-      </p:graphicFrame>
-      <p:sp>
-        <p:nvSpPr>
-          <p:cNvPr id="12" name="whatif-card"/>
-          <p:cNvSpPr/>
-          <p:nvPr/>
-        </p:nvSpPr>
-        <p:spPr>
-          <a:xfrm>
-            <a:off x="3840480" y="4526280"/>
-            <a:ext cx="7799832" cy="1417320"/>
-          </a:xfrm>
-          <a:prstGeom prst="roundRect">
-            <a:avLst>
-              <a:gd name="adj" fmla="val 9677"/>
-            </a:avLst>
-          </a:prstGeom>
-          <a:solidFill>
-            <a:srgbClr val="EEF7F2"/>
-          </a:solidFill>
-          <a:ln w="12700">
-            <a:solidFill>
-              <a:srgbClr val="EEF7F2"/>
-            </a:solidFill>
-            <a:prstDash val="solid"/>
-          </a:ln>
-          <a:effectLst>
-            <a:outerShdw sx="100000" sy="100000" kx="0" ky="0" algn="bl" rotWithShape="0" blurRad="101600" dist="25400" dir="5400000">
-              <a:srgbClr val="8FB5A6">
-                <a:alpha val="25000"/>
-              </a:srgbClr>
-            </a:outerShdw>
-          </a:effectLst>
-        </p:spPr>
-      </p:sp>
-      <p:sp>
-        <p:nvSpPr>
-          <p:cNvPr id="13" name="Text 10"/>
-          <p:cNvSpPr txBox="1"/>
-          <p:nvPr/>
-        </p:nvSpPr>
-        <p:spPr>
-          <a:xfrm>
-            <a:off x="4114800" y="4663440"/>
-            <a:ext cx="3657600" cy="365760"/>
+      <p:sp>
+        <p:nvSpPr>
+          <p:cNvPr id="10" name="Text 7"/>
+          <p:cNvSpPr txBox="1"/>
+          <p:nvPr/>
+        </p:nvSpPr>
+        <p:spPr>
+          <a:xfrm>
+            <a:off x="8321040" y="1645920"/>
+            <a:ext cx="3108960" cy="411480"/>
           </a:xfrm>
           <a:prstGeom prst="rect">
             <a:avLst/>
@@ -8429,13 +9811,13 @@
             <a:r>
               <a:rPr lang="en-US" sz="2000" b="1" dirty="0">
                 <a:solidFill>
-                  <a:srgbClr val="3FA796"/>
+                  <a:srgbClr val="3C8FC4"/>
                 </a:solidFill>
                 <a:latin typeface="Cambria" pitchFamily="34" charset="0"/>
                 <a:ea typeface="Cambria" pitchFamily="34" charset="-122"/>
                 <a:cs typeface="Cambria" pitchFamily="34" charset="-120"/>
               </a:rPr>
-              <a:t>What-if simulation</a:t>
+              <a:t>What SHAP does</a:t>
             </a:r>
             <a:endParaRPr lang="en-US" sz="2000" dirty="0"/>
           </a:p>
@@ -8443,14 +9825,14 @@
       </p:sp>
       <p:sp>
         <p:nvSpPr>
-          <p:cNvPr id="14" name="Text 11"/>
-          <p:cNvSpPr txBox="1"/>
-          <p:nvPr/>
-        </p:nvSpPr>
-        <p:spPr>
-          <a:xfrm>
-            <a:off x="4114800" y="5074920"/>
-            <a:ext cx="7315200" cy="731520"/>
+          <p:cNvPr id="11" name="Text 8"/>
+          <p:cNvSpPr txBox="1"/>
+          <p:nvPr/>
+        </p:nvSpPr>
+        <p:spPr>
+          <a:xfrm>
+            <a:off x="8321040" y="2194560"/>
+            <a:ext cx="3108960" cy="3566160"/>
           </a:xfrm>
           <a:prstGeom prst="rect">
             <a:avLst/>
@@ -8466,7 +9848,7 @@
               <a:buNone/>
             </a:pPr>
             <a:r>
-              <a:rPr lang="en-US" sz="1600" dirty="0">
+              <a:rPr lang="en-US" sz="1500" dirty="0">
                 <a:solidFill>
                   <a:srgbClr val="1F3A33"/>
                 </a:solidFill>
@@ -8474,9 +9856,9 @@
                 <a:ea typeface="Calibri" pitchFamily="34" charset="-122"/>
                 <a:cs typeface="Calibri" pitchFamily="34" charset="-120"/>
               </a:rPr>
-              <a:t>Slide steps or sleep up or down and the twin re-scores the 2 hour risk instantly.</a:t>
-            </a:r>
-            <a:endParaRPr lang="en-US" sz="1600" dirty="0"/>
+              <a:t>Shares credit for one prediction among the features, like splitting a team prize fairly. The dashboard shows the push of each feature for the chosen patient and moment. It explains the model, not biology.</a:t>
+            </a:r>
+            <a:endParaRPr lang="en-US" sz="1500" dirty="0"/>
           </a:p>
         </p:txBody>
       </p:sp>
@@ -8545,7 +9927,7 @@
                 <a:ea typeface="Cambria" pitchFamily="34" charset="-122"/>
                 <a:cs typeface="Cambria" pitchFamily="34" charset="-120"/>
               </a:rPr>
-              <a:t>Why it matters, and what to be honest about</a:t>
+              <a:t>Doctor's view of the virtual patient</a:t>
             </a:r>
             <a:endParaRPr lang="en-US" sz="3600" dirty="0"/>
           </a:p>
@@ -8631,18 +10013,18 @@
       </p:sp>
       <p:sp>
         <p:nvSpPr>
-          <p:cNvPr id="5" name="india-card"/>
+          <p:cNvPr id="5" name="patient-card"/>
           <p:cNvSpPr/>
           <p:nvPr/>
         </p:nvSpPr>
         <p:spPr>
           <a:xfrm>
-            <a:off x="548640" y="1554480"/>
-            <a:ext cx="5440680" cy="3566160"/>
+            <a:off x="548640" y="1463040"/>
+            <a:ext cx="3017520" cy="4480560"/>
           </a:xfrm>
           <a:prstGeom prst="roundRect">
             <a:avLst>
-              <a:gd name="adj" fmla="val 3846"/>
+              <a:gd name="adj" fmla="val 4545"/>
             </a:avLst>
           </a:prstGeom>
           <a:solidFill>
@@ -8671,8 +10053,8 @@
         </p:nvSpPr>
         <p:spPr>
           <a:xfrm>
-            <a:off x="822960" y="1783080"/>
-            <a:ext cx="4937760" cy="457200"/>
+            <a:off x="822960" y="1691640"/>
+            <a:ext cx="2560320" cy="411480"/>
           </a:xfrm>
           <a:prstGeom prst="rect">
             <a:avLst/>
@@ -8688,7 +10070,7 @@
               <a:buNone/>
             </a:pPr>
             <a:r>
-              <a:rPr lang="en-US" sz="2400" b="1" dirty="0">
+              <a:rPr lang="en-US" sz="2200" b="1" dirty="0">
                 <a:solidFill>
                   <a:srgbClr val="3FA796"/>
                 </a:solidFill>
@@ -8696,9 +10078,9 @@
                 <a:ea typeface="Cambria" pitchFamily="34" charset="-122"/>
                 <a:cs typeface="Cambria" pitchFamily="34" charset="-120"/>
               </a:rPr>
-              <a:t>Relevance to India</a:t>
-            </a:r>
-            <a:endParaRPr lang="en-US" sz="2400" dirty="0"/>
+              <a:t>Patient #3</a:t>
+            </a:r>
+            <a:endParaRPr lang="en-US" sz="2200" dirty="0"/>
           </a:p>
         </p:txBody>
       </p:sp>
@@ -8710,8 +10092,8 @@
         </p:nvSpPr>
         <p:spPr>
           <a:xfrm>
-            <a:off x="822960" y="2423160"/>
-            <a:ext cx="4937760" cy="2468880"/>
+            <a:off x="822960" y="2240280"/>
+            <a:ext cx="2468880" cy="2011680"/>
           </a:xfrm>
           <a:prstGeom prst="rect">
             <a:avLst/>
@@ -8723,15 +10105,11 @@
           <a:bodyPr wrap="square" lIns="0" tIns="0" rIns="0" bIns="0" rtlCol="0" anchor="t"/>
           <a:lstStyle/>
           <a:p>
-            <a:pPr marL="342900" indent="-342900">
-              <a:spcAft>
-                <a:spcPts val="1000"/>
-              </a:spcAft>
-              <a:buSzPct val="100000"/>
-              <a:buChar char="•"/>
-            </a:pPr>
-            <a:r>
-              <a:rPr lang="en-US" sz="1800" dirty="0">
+            <a:pPr indent="0" marL="0">
+              <a:buNone/>
+            </a:pPr>
+            <a:r>
+              <a:rPr lang="en-US" sz="1600" dirty="0">
                 <a:solidFill>
                   <a:srgbClr val="1F3A33"/>
                 </a:solidFill>
@@ -8739,89 +10117,26 @@
                 <a:ea typeface="Calibri" pitchFamily="34" charset="-122"/>
                 <a:cs typeface="Calibri" pitchFamily="34" charset="-120"/>
               </a:rPr>
-              <a:t>Huge and growing T2D burden</a:t>
-            </a:r>
-            <a:endParaRPr lang="en-US" sz="1800" dirty="0"/>
-          </a:p>
-          <a:p>
-            <a:pPr marL="342900" indent="-342900">
-              <a:spcAft>
-                <a:spcPts val="1000"/>
-              </a:spcAft>
-              <a:buSzPct val="100000"/>
-              <a:buChar char="•"/>
-            </a:pPr>
-            <a:r>
-              <a:rPr lang="en-US" sz="1800" dirty="0">
-                <a:solidFill>
-                  <a:srgbClr val="1F3A33"/>
-                </a:solidFill>
-                <a:latin typeface="Calibri" pitchFamily="34" charset="0"/>
-                <a:ea typeface="Calibri" pitchFamily="34" charset="-122"/>
-                <a:cs typeface="Calibri" pitchFamily="34" charset="-120"/>
-              </a:rPr>
-              <a:t>Carbohydrate-heavy diets</a:t>
-            </a:r>
-            <a:endParaRPr lang="en-US" sz="1800" dirty="0"/>
-          </a:p>
-          <a:p>
-            <a:pPr marL="342900" indent="-342900">
-              <a:spcAft>
-                <a:spcPts val="1000"/>
-              </a:spcAft>
-              <a:buSzPct val="100000"/>
-              <a:buChar char="•"/>
-            </a:pPr>
-            <a:r>
-              <a:rPr lang="en-US" sz="1800" dirty="0">
-                <a:solidFill>
-                  <a:srgbClr val="1F3A33"/>
-                </a:solidFill>
-                <a:latin typeface="Calibri" pitchFamily="34" charset="0"/>
-                <a:ea typeface="Calibri" pitchFamily="34" charset="-122"/>
-                <a:cs typeface="Calibri" pitchFamily="34" charset="-120"/>
-              </a:rPr>
-              <a:t>Low-cost wearables and CGM are spreading</a:t>
-            </a:r>
-            <a:endParaRPr lang="en-US" sz="1800" dirty="0"/>
-          </a:p>
-          <a:p>
-            <a:pPr marL="342900" indent="-342900">
-              <a:spcAft>
-                <a:spcPts val="1000"/>
-              </a:spcAft>
-              <a:buSzPct val="100000"/>
-              <a:buChar char="•"/>
-            </a:pPr>
-            <a:r>
-              <a:rPr lang="en-US" sz="1800" dirty="0">
-                <a:solidFill>
-                  <a:srgbClr val="1F3A33"/>
-                </a:solidFill>
-                <a:latin typeface="Calibri" pitchFamily="34" charset="0"/>
-                <a:ea typeface="Calibri" pitchFamily="34" charset="-122"/>
-                <a:cs typeface="Calibri" pitchFamily="34" charset="-120"/>
-              </a:rPr>
-              <a:t>Proactive alerts support earlier intervention</a:t>
-            </a:r>
-            <a:endParaRPr lang="en-US" sz="1800" dirty="0"/>
-          </a:p>
-        </p:txBody>
-      </p:sp>
-      <p:sp>
-        <p:nvSpPr>
-          <p:cNvPr id="8" name="limits-card"/>
+              <a:t>EHR card: age, BMI, HbA1c, eGFR, medication, genetic risk, with live glucose, sleep and steps</a:t>
+            </a:r>
+            <a:endParaRPr lang="en-US" sz="1600" dirty="0"/>
+          </a:p>
+        </p:txBody>
+      </p:sp>
+      <p:sp>
+        <p:nvSpPr>
+          <p:cNvPr id="8" name="alert-pill"/>
           <p:cNvSpPr/>
           <p:nvPr/>
         </p:nvSpPr>
         <p:spPr>
           <a:xfrm>
-            <a:off x="6199632" y="1554480"/>
-            <a:ext cx="5440680" cy="3566160"/>
+            <a:off x="822960" y="4572000"/>
+            <a:ext cx="2468880" cy="1005840"/>
           </a:xfrm>
           <a:prstGeom prst="roundRect">
             <a:avLst>
-              <a:gd name="adj" fmla="val 3846"/>
+              <a:gd name="adj" fmla="val 10909"/>
             </a:avLst>
           </a:prstGeom>
           <a:solidFill>
@@ -8830,6 +10145,72 @@
           <a:ln w="12700">
             <a:solidFill>
               <a:srgbClr val="FDEBE3"/>
+            </a:solidFill>
+            <a:prstDash val="solid"/>
+          </a:ln>
+        </p:spPr>
+      </p:sp>
+      <p:sp>
+        <p:nvSpPr>
+          <p:cNvPr id="9" name="Text 7"/>
+          <p:cNvSpPr txBox="1"/>
+          <p:nvPr/>
+        </p:nvSpPr>
+        <p:spPr>
+          <a:xfrm>
+            <a:off x="960120" y="4617720"/>
+            <a:ext cx="2194560" cy="914400"/>
+          </a:xfrm>
+          <a:prstGeom prst="rect">
+            <a:avLst/>
+          </a:prstGeom>
+          <a:noFill/>
+          <a:ln/>
+        </p:spPr>
+        <p:txBody>
+          <a:bodyPr wrap="square" lIns="0" tIns="0" rIns="0" bIns="0" rtlCol="0" anchor="ctr"/>
+          <a:lstStyle/>
+          <a:p>
+            <a:pPr indent="0" marL="0">
+              <a:buNone/>
+            </a:pPr>
+            <a:r>
+              <a:rPr lang="en-US" sz="1400" b="1" dirty="0">
+                <a:solidFill>
+                  <a:srgbClr val="9C4A2F"/>
+                </a:solidFill>
+                <a:latin typeface="Calibri" pitchFamily="34" charset="0"/>
+                <a:ea typeface="Calibri" pitchFamily="34" charset="-122"/>
+                <a:cs typeface="Calibri" pitchFamily="34" charset="-120"/>
+              </a:rPr>
+              <a:t>Separate HIGH and LOW alerts with adjustable thresholds</a:t>
+            </a:r>
+            <a:endParaRPr lang="en-US" sz="1400" dirty="0"/>
+          </a:p>
+        </p:txBody>
+      </p:sp>
+      <p:sp>
+        <p:nvSpPr>
+          <p:cNvPr id="10" name="glucose-card"/>
+          <p:cNvSpPr/>
+          <p:nvPr/>
+        </p:nvSpPr>
+        <p:spPr>
+          <a:xfrm>
+            <a:off x="3840480" y="1463040"/>
+            <a:ext cx="7799832" cy="2834640"/>
+          </a:xfrm>
+          <a:prstGeom prst="roundRect">
+            <a:avLst>
+              <a:gd name="adj" fmla="val 4839"/>
+            </a:avLst>
+          </a:prstGeom>
+          <a:solidFill>
+            <a:srgbClr val="E4F1FA"/>
+          </a:solidFill>
+          <a:ln w="12700">
+            <a:solidFill>
+              <a:srgbClr val="E4F1FA"/>
             </a:solidFill>
             <a:prstDash val="solid"/>
           </a:ln>
@@ -8842,16 +10223,66 @@
           </a:effectLst>
         </p:spPr>
       </p:sp>
-      <p:sp>
-        <p:nvSpPr>
-          <p:cNvPr id="9" name="Text 7"/>
-          <p:cNvSpPr txBox="1"/>
-          <p:nvPr/>
-        </p:nvSpPr>
-        <p:spPr>
-          <a:xfrm>
-            <a:off x="6473952" y="1783080"/>
-            <a:ext cx="4937760" cy="457200"/>
+      <p:graphicFrame>
+        <p:nvGraphicFramePr>
+          <p:cNvPr id="11" name="Chart 0" descr=""/>
+          <p:cNvGraphicFramePr/>
+          <p:nvPr/>
+        </p:nvGraphicFramePr>
+        <p:xfrm>
+          <a:off x="3977640" y="1554480"/>
+          <a:ext cx="7498080" cy="2651760"/>
+        </p:xfrm>
+        <a:graphic xmlns:a="http://schemas.openxmlformats.org/drawingml/2006/main">
+          <a:graphicData uri="http://schemas.openxmlformats.org/drawingml/2006/chart">
+            <c:chart xmlns:c="http://schemas.openxmlformats.org/drawingml/2006/chart" r:id="rId1"/>
+          </a:graphicData>
+        </a:graphic>
+      </p:graphicFrame>
+      <p:sp>
+        <p:nvSpPr>
+          <p:cNvPr id="12" name="whatif-card"/>
+          <p:cNvSpPr/>
+          <p:nvPr/>
+        </p:nvSpPr>
+        <p:spPr>
+          <a:xfrm>
+            <a:off x="3840480" y="4526280"/>
+            <a:ext cx="7799832" cy="1417320"/>
+          </a:xfrm>
+          <a:prstGeom prst="roundRect">
+            <a:avLst>
+              <a:gd name="adj" fmla="val 9677"/>
+            </a:avLst>
+          </a:prstGeom>
+          <a:solidFill>
+            <a:srgbClr val="EEF7F2"/>
+          </a:solidFill>
+          <a:ln w="12700">
+            <a:solidFill>
+              <a:srgbClr val="EEF7F2"/>
+            </a:solidFill>
+            <a:prstDash val="solid"/>
+          </a:ln>
+          <a:effectLst>
+            <a:outerShdw sx="100000" sy="100000" kx="0" ky="0" algn="bl" rotWithShape="0" blurRad="101600" dist="25400" dir="5400000">
+              <a:srgbClr val="8FB5A6">
+                <a:alpha val="25000"/>
+              </a:srgbClr>
+            </a:outerShdw>
+          </a:effectLst>
+        </p:spPr>
+      </p:sp>
+      <p:sp>
+        <p:nvSpPr>
+          <p:cNvPr id="13" name="Text 10"/>
+          <p:cNvSpPr txBox="1"/>
+          <p:nvPr/>
+        </p:nvSpPr>
+        <p:spPr>
+          <a:xfrm>
+            <a:off x="4114800" y="4663440"/>
+            <a:ext cx="3657600" cy="365760"/>
           </a:xfrm>
           <a:prstGeom prst="rect">
             <a:avLst/>
@@ -8867,30 +10298,30 @@
               <a:buNone/>
             </a:pPr>
             <a:r>
-              <a:rPr lang="en-US" sz="2400" b="1" dirty="0">
-                <a:solidFill>
-                  <a:srgbClr val="C0603F"/>
+              <a:rPr lang="en-US" sz="2000" b="1" dirty="0">
+                <a:solidFill>
+                  <a:srgbClr val="3FA796"/>
                 </a:solidFill>
                 <a:latin typeface="Cambria" pitchFamily="34" charset="0"/>
                 <a:ea typeface="Cambria" pitchFamily="34" charset="-122"/>
                 <a:cs typeface="Cambria" pitchFamily="34" charset="-120"/>
               </a:rPr>
-              <a:t>Limitations</a:t>
-            </a:r>
-            <a:endParaRPr lang="en-US" sz="2400" dirty="0"/>
-          </a:p>
-        </p:txBody>
-      </p:sp>
-      <p:sp>
-        <p:nvSpPr>
-          <p:cNvPr id="10" name="Text 8"/>
-          <p:cNvSpPr txBox="1"/>
-          <p:nvPr/>
-        </p:nvSpPr>
-        <p:spPr>
-          <a:xfrm>
-            <a:off x="6473952" y="2423160"/>
-            <a:ext cx="4937760" cy="2468880"/>
+              <a:t>What-if simulation</a:t>
+            </a:r>
+            <a:endParaRPr lang="en-US" sz="2000" dirty="0"/>
+          </a:p>
+        </p:txBody>
+      </p:sp>
+      <p:sp>
+        <p:nvSpPr>
+          <p:cNvPr id="14" name="Text 11"/>
+          <p:cNvSpPr txBox="1"/>
+          <p:nvPr/>
+        </p:nvSpPr>
+        <p:spPr>
+          <a:xfrm>
+            <a:off x="4114800" y="5074920"/>
+            <a:ext cx="7315200" cy="731520"/>
           </a:xfrm>
           <a:prstGeom prst="rect">
             <a:avLst/>
@@ -8902,15 +10333,11 @@
           <a:bodyPr wrap="square" lIns="0" tIns="0" rIns="0" bIns="0" rtlCol="0" anchor="t"/>
           <a:lstStyle/>
           <a:p>
-            <a:pPr marL="342900" indent="-342900">
-              <a:spcAft>
-                <a:spcPts val="1000"/>
-              </a:spcAft>
-              <a:buSzPct val="100000"/>
-              <a:buChar char="•"/>
-            </a:pPr>
-            <a:r>
-              <a:rPr lang="en-US" sz="1800" dirty="0">
+            <a:pPr indent="0" marL="0">
+              <a:buNone/>
+            </a:pPr>
+            <a:r>
+              <a:rPr lang="en-US" sz="1600" dirty="0">
                 <a:solidFill>
                   <a:srgbClr val="1F3A33"/>
                 </a:solidFill>
@@ -8918,72 +10345,9 @@
                 <a:ea typeface="Calibri" pitchFamily="34" charset="-122"/>
                 <a:cs typeface="Calibri" pitchFamily="34" charset="-120"/>
               </a:rPr>
-              <a:t>Synthetic data: results are an upper bound</a:t>
-            </a:r>
-            <a:endParaRPr lang="en-US" sz="1800" dirty="0"/>
-          </a:p>
-          <a:p>
-            <a:pPr marL="342900" indent="-342900">
-              <a:spcAft>
-                <a:spcPts val="1000"/>
-              </a:spcAft>
-              <a:buSzPct val="100000"/>
-              <a:buChar char="•"/>
-            </a:pPr>
-            <a:r>
-              <a:rPr lang="en-US" sz="1800" dirty="0">
-                <a:solidFill>
-                  <a:srgbClr val="1F3A33"/>
-                </a:solidFill>
-                <a:latin typeface="Calibri" pitchFamily="34" charset="0"/>
-                <a:ea typeface="Calibri" pitchFamily="34" charset="-122"/>
-                <a:cs typeface="Calibri" pitchFamily="34" charset="-120"/>
-              </a:rPr>
-              <a:t>Simulator encodes assumed physiology</a:t>
-            </a:r>
-            <a:endParaRPr lang="en-US" sz="1800" dirty="0"/>
-          </a:p>
-          <a:p>
-            <a:pPr marL="342900" indent="-342900">
-              <a:spcAft>
-                <a:spcPts val="1000"/>
-              </a:spcAft>
-              <a:buSzPct val="100000"/>
-              <a:buChar char="•"/>
-            </a:pPr>
-            <a:r>
-              <a:rPr lang="en-US" sz="1800" dirty="0">
-                <a:solidFill>
-                  <a:srgbClr val="1F3A33"/>
-                </a:solidFill>
-                <a:latin typeface="Calibri" pitchFamily="34" charset="0"/>
-                <a:ea typeface="Calibri" pitchFamily="34" charset="-122"/>
-                <a:cs typeface="Calibri" pitchFamily="34" charset="-120"/>
-              </a:rPr>
-              <a:t>Predicts high glucose only, not lows</a:t>
-            </a:r>
-            <a:endParaRPr lang="en-US" sz="1800" dirty="0"/>
-          </a:p>
-          <a:p>
-            <a:pPr marL="342900" indent="-342900">
-              <a:spcAft>
-                <a:spcPts val="1000"/>
-              </a:spcAft>
-              <a:buSzPct val="100000"/>
-              <a:buChar char="•"/>
-            </a:pPr>
-            <a:r>
-              <a:rPr lang="en-US" sz="1800" dirty="0">
-                <a:solidFill>
-                  <a:srgbClr val="1F3A33"/>
-                </a:solidFill>
-                <a:latin typeface="Calibri" pitchFamily="34" charset="0"/>
-                <a:ea typeface="Calibri" pitchFamily="34" charset="-122"/>
-                <a:cs typeface="Calibri" pitchFamily="34" charset="-120"/>
-              </a:rPr>
-              <a:t>Not a medical device; not clinically validated</a:t>
-            </a:r>
-            <a:endParaRPr lang="en-US" sz="1800" dirty="0"/>
+              <a:t>Slide steps or sleep up or down and the twin re-scores both 2 hour risks instantly.</a:t>
+            </a:r>
+            <a:endParaRPr lang="en-US" sz="1600" dirty="0"/>
           </a:p>
         </p:txBody>
       </p:sp>

</xml_diff>